<commit_message>
docs 23/10: progress report and deck updated - owner's edits kept, no CI, figures in the report, operational alert test, RCA IP mapping fix and example tree, feature groups under CUSUM cap
</commit_message>
<xml_diff>
--- a/docs/Slide-runtime_security(23_10).pptx
+++ b/docs/Slide-runtime_security(23_10).pptx
@@ -23,9 +23,10 @@
     <p:sldId id="271" r:id="rId17"/>
     <p:sldId id="272" r:id="rId18"/>
     <p:sldId id="273" r:id="rId19"/>
+    <p:sldId id="274" r:id="rId20"/>
   </p:sldIdLst>
   <p:notesMasterIdLst>
-    <p:notesMasterId r:id="rId20"/>
+    <p:notesMasterId r:id="rId21"/>
   </p:notesMasterIdLst>
   <p:sldSz cx="12192000" cy="6858000"/>
   <p:notesSz cx="6858000" cy="12192000"/>
@@ -124,17 +125,17 @@
   <p:extLst>
     <p:ext uri="{521415D9-36F7-43E2-AB2F-B90AF26B5E84}">
       <p14:sectionLst xmlns:p14="http://schemas.microsoft.com/office/powerpoint/2010/main">
-        <p14:section name="Mở đầu" id="{3f84c111-2e2f-1f99-6155-bec200b98ba3}">
+        <p14:section name="Mở đầu" id="{45f3b1db-da56-8361-fa55-872091d22552}">
           <p14:sldIdLst>
             <p14:sldId id="256"/>
           </p14:sldIdLst>
         </p14:section>
-        <p14:section name="Tổng quan tuần" id="{1d376bbd-ff5f-e7d8-1859-63481b86c541}">
+        <p14:section name="Tổng quan tuần" id="{ad1bcbed-7ccb-9a6f-ec43-480915594374}">
           <p14:sldIdLst>
             <p14:sldId id="257"/>
           </p14:sldIdLst>
         </p14:section>
-        <p14:section name="Thí nghiệm 1 – Sentinel Pulse" id="{dadc5a06-14eb-9c78-d40e-ea2788ad5f61}">
+        <p14:section name="Thí nghiệm 1 – Sentinel Pulse" id="{c58853c0-88c0-9867-f475-296ccbe45472}">
           <p14:sldIdLst>
             <p14:sldId id="258"/>
             <p14:sldId id="259"/>
@@ -145,25 +146,26 @@
             <p14:sldId id="264"/>
             <p14:sldId id="265"/>
             <p14:sldId id="266"/>
+            <p14:sldId id="267"/>
           </p14:sldIdLst>
         </p14:section>
-        <p14:section name="Thí nghiệm 2 – Syscall và nhóm feature" id="{ddda5cae-9b1e-f572-8629-d53cafee6d81}">
+        <p14:section name="Thí nghiệm 2 – Syscall và nhóm feature" id="{b8cfd1b4-b538-cc5f-ee9a-b16d6664daee}">
           <p14:sldIdLst>
-            <p14:sldId id="267"/>
             <p14:sldId id="268"/>
             <p14:sldId id="269"/>
+            <p14:sldId id="270"/>
           </p14:sldIdLst>
         </p14:section>
-        <p14:section name="Thí nghiệm 3 – RCA" id="{f7eb0c0b-f622-b606-76a0-e38819bbc9b1}">
+        <p14:section name="Thí nghiệm 3 – RCA" id="{63b173ac-8b53-47b4-8a31-5e3ec15fe049}">
           <p14:sldIdLst>
-            <p14:sldId id="270"/>
             <p14:sldId id="271"/>
+            <p14:sldId id="272"/>
           </p14:sldIdLst>
         </p14:section>
-        <p14:section name="Phần rule và việc tiếp theo" id="{5e6beb75-5050-aff8-ffbd-74da36135596}">
+        <p14:section name="Phần rule và việc tiếp theo" id="{3da96059-d9a7-f59c-6e85-51b915be045c}">
           <p14:sldIdLst>
-            <p14:sldId id="272"/>
             <p14:sldId id="273"/>
+            <p14:sldId id="274"/>
           </p14:sldIdLst>
         </p14:section>
       </p14:sectionLst>
@@ -1404,6 +1406,94 @@
 </p:notes>
 </file>
 
+<file path=ppt/notesSlides/notesSlide19.xml><?xml version="1.0" encoding="utf-8"?>
+<p:notes xmlns:a="http://schemas.openxmlformats.org/drawingml/2006/main" xmlns:r="http://schemas.openxmlformats.org/officeDocument/2006/relationships" xmlns:p="http://schemas.openxmlformats.org/presentationml/2006/main">
+  <p:cSld>
+    <p:spTree>
+      <p:nvGrpSpPr>
+        <p:cNvPr id="1" name=""/>
+        <p:cNvGrpSpPr/>
+        <p:nvPr/>
+      </p:nvGrpSpPr>
+      <p:grpSpPr>
+        <a:xfrm>
+          <a:off x="0" y="0"/>
+          <a:ext cx="0" cy="0"/>
+          <a:chOff x="0" y="0"/>
+          <a:chExt cx="0" cy="0"/>
+        </a:xfrm>
+      </p:grpSpPr>
+      <p:sp>
+        <p:nvSpPr>
+          <p:cNvPr id="2" name="Slide Image Placeholder 1"/>
+          <p:cNvSpPr>
+            <a:spLocks noGrp="1" noRot="1" noChangeAspect="1"/>
+          </p:cNvSpPr>
+          <p:nvPr>
+            <p:ph type="sldImg"/>
+          </p:nvPr>
+        </p:nvSpPr>
+        <p:spPr/>
+      </p:sp>
+      <p:sp>
+        <p:nvSpPr>
+          <p:cNvPr id="3" name="Notes Placeholder 2"/>
+          <p:cNvSpPr>
+            <a:spLocks noGrp="1"/>
+          </p:cNvSpPr>
+          <p:nvPr>
+            <p:ph type="body" idx="1"/>
+          </p:nvPr>
+        </p:nvSpPr>
+        <p:spPr/>
+        <p:txBody>
+          <a:bodyPr/>
+          <a:lstStyle/>
+          <a:p>
+            <a:r>
+              <a:rPr lang="en-US" dirty="0"/>
+              <a:t/>
+            </a:r>
+            <a:endParaRPr lang="en-US" dirty="0"/>
+          </a:p>
+        </p:txBody>
+      </p:sp>
+      <p:sp>
+        <p:nvSpPr>
+          <p:cNvPr id="4" name="Slide Number Placeholder 3"/>
+          <p:cNvSpPr>
+            <a:spLocks noGrp="1"/>
+          </p:cNvSpPr>
+          <p:nvPr>
+            <p:ph type="sldNum" sz="quarter" idx="10"/>
+          </p:nvPr>
+        </p:nvSpPr>
+        <p:spPr/>
+        <p:txBody>
+          <a:bodyPr/>
+          <a:lstStyle/>
+          <a:p>
+            <a:fld id="{F7021451-1387-4CA6-816F-3879F97B5CBC}" type="slidenum">
+              <a:rPr lang="en-US"/>
+              <a:t>19</a:t>
+            </a:fld>
+            <a:endParaRPr lang="en-US"/>
+          </a:p>
+        </p:txBody>
+      </p:sp>
+    </p:spTree>
+    <p:extLst>
+      <p:ext uri="{BB962C8B-B14F-4D97-AF65-F5344CB8AC3E}">
+        <p14:creationId xmlns:p14="http://schemas.microsoft.com/office/powerpoint/2010/main" val="1024086991"/>
+      </p:ext>
+    </p:extLst>
+  </p:cSld>
+  <p:clrMapOvr>
+    <a:masterClrMapping/>
+  </p:clrMapOvr>
+</p:notes>
+</file>
+
 <file path=ppt/notesSlides/notesSlide2.xml><?xml version="1.0" encoding="utf-8"?>
 <p:notes xmlns:a="http://schemas.openxmlformats.org/drawingml/2006/main" xmlns:r="http://schemas.openxmlformats.org/officeDocument/2006/relationships" xmlns:p="http://schemas.openxmlformats.org/presentationml/2006/main">
   <p:cSld>
@@ -2619,7 +2709,7 @@
                   <a:schemeClr val="tx1"/>
                 </a:solidFill>
               </a:rPr>
-              <a:t>Calibration và luật gộp theo thời gian, binary vô hại, baseline, CUSUM và lỗi "nhớ" alarm, cấu hình ML stable, gánh cảnh báo, overhead</a:t>
+              <a:t>Calibration và luật gộp theo thời gian, binary vô hại, baseline, CUSUM và lỗi "nhớ" alarm, cấu hình ML stable, gánh cảnh báo, overhead, cảnh báo vận hành thật</a:t>
             </a:r>
             <a:endParaRPr lang="en-US" sz="1800" dirty="0"/>
           </a:p>
@@ -6153,7 +6243,7 @@
                   <a:schemeClr val="tx1"/>
                 </a:solidFill>
               </a:rPr>
-              <a:t>3 điều kiện (tắt / gắn nhưng không theo dõi / theo dõi), luân phiên 5 vòng, CI 95% bootstrap</a:t>
+              <a:t>3 điều kiện (tắt / gắn nhưng không theo dõi / theo dõi), luân phiên 5 vòng</a:t>
             </a:r>
             <a:endParaRPr lang="en-US" sz="1800" dirty="0"/>
           </a:p>
@@ -6222,6 +6312,1211 @@
 <file path=ppt/slides/slide12.xml><?xml version="1.0" encoding="utf-8"?>
 <p:sld xmlns:a="http://schemas.openxmlformats.org/drawingml/2006/main" xmlns:r="http://schemas.openxmlformats.org/officeDocument/2006/relationships" xmlns:p="http://schemas.openxmlformats.org/presentationml/2006/main">
   <p:cSld name="Slide 12">
+    <p:spTree>
+      <p:nvGrpSpPr>
+        <p:cNvPr id="1" name=""/>
+        <p:cNvGrpSpPr/>
+        <p:nvPr/>
+      </p:nvGrpSpPr>
+      <p:grpSpPr>
+        <a:xfrm>
+          <a:off x="0" y="0"/>
+          <a:ext cx="0" cy="0"/>
+          <a:chOff x="0" y="0"/>
+          <a:chExt cx="0" cy="0"/>
+        </a:xfrm>
+      </p:grpSpPr>
+      <p:sp>
+        <p:nvSpPr>
+          <p:cNvPr id="2" name="Text 0"/>
+          <p:cNvSpPr/>
+          <p:nvPr>
+            <p:ph idx="100" type="title" hasCustomPrompt="1"/>
+          </p:nvPr>
+        </p:nvSpPr>
+        <p:spPr>
+          <a:xfrm>
+            <a:off x="813816" y="512064"/>
+            <a:ext cx="10881360" cy="411480"/>
+          </a:xfrm>
+          <a:prstGeom prst="rect">
+            <a:avLst/>
+          </a:prstGeom>
+          <a:noFill/>
+          <a:ln/>
+        </p:spPr>
+        <p:txBody>
+          <a:bodyPr wrap="square" lIns="0" tIns="0" rIns="0" bIns="0" rtlCol="0" anchor="ctr"/>
+          <a:lstStyle/>
+          <a:p>
+            <a:pPr algn="l" indent="0" marL="0">
+              <a:buNone/>
+            </a:pPr>
+            <a:r>
+              <a:rPr lang="en-US" sz="2200" b="1" dirty="0">
+                <a:solidFill>
+                  <a:schemeClr val="tx1"/>
+                </a:solidFill>
+              </a:rPr>
+              <a:t>Thí nghiệm 1 – Cảnh báo vận hành thật qua Prometheus/Alertmanager</a:t>
+            </a:r>
+            <a:endParaRPr lang="en-US" sz="2200" dirty="0"/>
+          </a:p>
+        </p:txBody>
+      </p:sp>
+      <p:graphicFrame>
+        <p:nvGraphicFramePr>
+          <p:cNvPr id="13" name="Bảng"/>
+          <p:cNvGraphicFramePr>
+            <a:graphicFrameLocks noGrp="1"/>
+          </p:cNvGraphicFramePr>
+          <p:nvPr>
+            <p:extLst>
+              <p:ext uri="{D42A27DB-BD31-4B8C-83A1-F6EECF244321}">
+                <p14:modId xmlns:p14="http://schemas.microsoft.com/office/powerpoint/2010/main" val="1579011935"/>
+              </p:ext>
+            </p:extLst>
+          </p:nvPr>
+        </p:nvGraphicFramePr>
+        <p:xfrm>
+          <a:off x="813816" y="1024128"/>
+          <a:ext cx="10881360" cy="914400"/>
+        </p:xfrm>
+        <a:graphic>
+          <a:graphicData uri="http://schemas.openxmlformats.org/drawingml/2006/table">
+            <a:tbl>
+              <a:tblPr/>
+              <a:tblGrid>
+                <a:gridCol w="5669280"/>
+                <a:gridCol w="2377440"/>
+                <a:gridCol w="1371600"/>
+                <a:gridCol w="1463040"/>
+              </a:tblGrid>
+              <a:tr h="329184">
+                <a:tc>
+                  <a:txBody>
+                    <a:bodyPr/>
+                    <a:lstStyle/>
+                    <a:p>
+                      <a:pPr algn="l" indent="0" marL="0">
+                        <a:buNone/>
+                      </a:pPr>
+                      <a:r>
+                        <a:rPr lang="en-US" sz="1600" b="1" dirty="0">
+                          <a:solidFill>
+                            <a:schemeClr val="tx1"/>
+                          </a:solidFill>
+                        </a:rPr>
+                        <a:t>Đường giao (cùng các đợt của lượt xác nhận)</a:t>
+                      </a:r>
+                      <a:endParaRPr lang="en-US" sz="1600" dirty="0"/>
+                    </a:p>
+                  </a:txBody>
+                  <a:tcPr marL="76200" marR="76200" marT="38100" marB="38100" anchor="ctr">
+                    <a:lnL w="9525" cap="flat" cmpd="sng" algn="ctr">
+                      <a:solidFill>
+                        <a:srgbClr val="BFBFBF"/>
+                      </a:solidFill>
+                      <a:prstDash val="solid"/>
+                      <a:round/>
+                      <a:headEnd type="none" w="med" len="med"/>
+                      <a:tailEnd type="none" w="med" len="med"/>
+                    </a:lnL>
+                    <a:lnR w="9525" cap="flat" cmpd="sng" algn="ctr">
+                      <a:solidFill>
+                        <a:srgbClr val="BFBFBF"/>
+                      </a:solidFill>
+                      <a:prstDash val="solid"/>
+                      <a:round/>
+                      <a:headEnd type="none" w="med" len="med"/>
+                      <a:tailEnd type="none" w="med" len="med"/>
+                    </a:lnR>
+                    <a:lnT w="9525" cap="flat" cmpd="sng" algn="ctr">
+                      <a:solidFill>
+                        <a:srgbClr val="BFBFBF"/>
+                      </a:solidFill>
+                      <a:prstDash val="solid"/>
+                      <a:round/>
+                      <a:headEnd type="none" w="med" len="med"/>
+                      <a:tailEnd type="none" w="med" len="med"/>
+                    </a:lnT>
+                    <a:lnB w="9525" cap="flat" cmpd="sng" algn="ctr">
+                      <a:solidFill>
+                        <a:srgbClr val="BFBFBF"/>
+                      </a:solidFill>
+                      <a:prstDash val="solid"/>
+                      <a:round/>
+                      <a:headEnd type="none" w="med" len="med"/>
+                      <a:tailEnd type="none" w="med" len="med"/>
+                    </a:lnB>
+                    <a:solidFill>
+                      <a:srgbClr val="F2F2F2"/>
+                    </a:solidFill>
+                  </a:tcPr>
+                </a:tc>
+                <a:tc>
+                  <a:txBody>
+                    <a:bodyPr/>
+                    <a:lstStyle/>
+                    <a:p>
+                      <a:pPr algn="r" indent="0" marL="0">
+                        <a:buNone/>
+                      </a:pPr>
+                      <a:r>
+                        <a:rPr lang="en-US" sz="1600" b="1" dirty="0">
+                          <a:solidFill>
+                            <a:schemeClr val="tx1"/>
+                          </a:solidFill>
+                        </a:rPr>
+                        <a:t>Đợt tới người nhận</a:t>
+                      </a:r>
+                      <a:endParaRPr lang="en-US" sz="1600" dirty="0"/>
+                    </a:p>
+                  </a:txBody>
+                  <a:tcPr marL="76200" marR="76200" marT="38100" marB="38100" anchor="ctr">
+                    <a:lnL w="9525" cap="flat" cmpd="sng" algn="ctr">
+                      <a:solidFill>
+                        <a:srgbClr val="BFBFBF"/>
+                      </a:solidFill>
+                      <a:prstDash val="solid"/>
+                      <a:round/>
+                      <a:headEnd type="none" w="med" len="med"/>
+                      <a:tailEnd type="none" w="med" len="med"/>
+                    </a:lnL>
+                    <a:lnR w="9525" cap="flat" cmpd="sng" algn="ctr">
+                      <a:solidFill>
+                        <a:srgbClr val="BFBFBF"/>
+                      </a:solidFill>
+                      <a:prstDash val="solid"/>
+                      <a:round/>
+                      <a:headEnd type="none" w="med" len="med"/>
+                      <a:tailEnd type="none" w="med" len="med"/>
+                    </a:lnR>
+                    <a:lnT w="9525" cap="flat" cmpd="sng" algn="ctr">
+                      <a:solidFill>
+                        <a:srgbClr val="BFBFBF"/>
+                      </a:solidFill>
+                      <a:prstDash val="solid"/>
+                      <a:round/>
+                      <a:headEnd type="none" w="med" len="med"/>
+                      <a:tailEnd type="none" w="med" len="med"/>
+                    </a:lnT>
+                    <a:lnB w="9525" cap="flat" cmpd="sng" algn="ctr">
+                      <a:solidFill>
+                        <a:srgbClr val="BFBFBF"/>
+                      </a:solidFill>
+                      <a:prstDash val="solid"/>
+                      <a:round/>
+                      <a:headEnd type="none" w="med" len="med"/>
+                      <a:tailEnd type="none" w="med" len="med"/>
+                    </a:lnB>
+                    <a:solidFill>
+                      <a:srgbClr val="F2F2F2"/>
+                    </a:solidFill>
+                  </a:tcPr>
+                </a:tc>
+                <a:tc>
+                  <a:txBody>
+                    <a:bodyPr/>
+                    <a:lstStyle/>
+                    <a:p>
+                      <a:pPr algn="r" indent="0" marL="0">
+                        <a:buNone/>
+                      </a:pPr>
+                      <a:r>
+                        <a:rPr lang="en-US" sz="1600" b="1" dirty="0">
+                          <a:solidFill>
+                            <a:schemeClr val="tx1"/>
+                          </a:solidFill>
+                        </a:rPr>
+                        <a:t>p50</a:t>
+                      </a:r>
+                      <a:endParaRPr lang="en-US" sz="1600" dirty="0"/>
+                    </a:p>
+                  </a:txBody>
+                  <a:tcPr marL="76200" marR="76200" marT="38100" marB="38100" anchor="ctr">
+                    <a:lnL w="9525" cap="flat" cmpd="sng" algn="ctr">
+                      <a:solidFill>
+                        <a:srgbClr val="BFBFBF"/>
+                      </a:solidFill>
+                      <a:prstDash val="solid"/>
+                      <a:round/>
+                      <a:headEnd type="none" w="med" len="med"/>
+                      <a:tailEnd type="none" w="med" len="med"/>
+                    </a:lnL>
+                    <a:lnR w="9525" cap="flat" cmpd="sng" algn="ctr">
+                      <a:solidFill>
+                        <a:srgbClr val="BFBFBF"/>
+                      </a:solidFill>
+                      <a:prstDash val="solid"/>
+                      <a:round/>
+                      <a:headEnd type="none" w="med" len="med"/>
+                      <a:tailEnd type="none" w="med" len="med"/>
+                    </a:lnR>
+                    <a:lnT w="9525" cap="flat" cmpd="sng" algn="ctr">
+                      <a:solidFill>
+                        <a:srgbClr val="BFBFBF"/>
+                      </a:solidFill>
+                      <a:prstDash val="solid"/>
+                      <a:round/>
+                      <a:headEnd type="none" w="med" len="med"/>
+                      <a:tailEnd type="none" w="med" len="med"/>
+                    </a:lnT>
+                    <a:lnB w="9525" cap="flat" cmpd="sng" algn="ctr">
+                      <a:solidFill>
+                        <a:srgbClr val="BFBFBF"/>
+                      </a:solidFill>
+                      <a:prstDash val="solid"/>
+                      <a:round/>
+                      <a:headEnd type="none" w="med" len="med"/>
+                      <a:tailEnd type="none" w="med" len="med"/>
+                    </a:lnB>
+                    <a:solidFill>
+                      <a:srgbClr val="F2F2F2"/>
+                    </a:solidFill>
+                  </a:tcPr>
+                </a:tc>
+                <a:tc>
+                  <a:txBody>
+                    <a:bodyPr/>
+                    <a:lstStyle/>
+                    <a:p>
+                      <a:pPr algn="r" indent="0" marL="0">
+                        <a:buNone/>
+                      </a:pPr>
+                      <a:r>
+                        <a:rPr lang="en-US" sz="1600" b="1" dirty="0">
+                          <a:solidFill>
+                            <a:schemeClr val="tx1"/>
+                          </a:solidFill>
+                        </a:rPr>
+                        <a:t>p95</a:t>
+                      </a:r>
+                      <a:endParaRPr lang="en-US" sz="1600" dirty="0"/>
+                    </a:p>
+                  </a:txBody>
+                  <a:tcPr marL="76200" marR="76200" marT="38100" marB="38100" anchor="ctr">
+                    <a:lnL w="9525" cap="flat" cmpd="sng" algn="ctr">
+                      <a:solidFill>
+                        <a:srgbClr val="BFBFBF"/>
+                      </a:solidFill>
+                      <a:prstDash val="solid"/>
+                      <a:round/>
+                      <a:headEnd type="none" w="med" len="med"/>
+                      <a:tailEnd type="none" w="med" len="med"/>
+                    </a:lnL>
+                    <a:lnR w="9525" cap="flat" cmpd="sng" algn="ctr">
+                      <a:solidFill>
+                        <a:srgbClr val="BFBFBF"/>
+                      </a:solidFill>
+                      <a:prstDash val="solid"/>
+                      <a:round/>
+                      <a:headEnd type="none" w="med" len="med"/>
+                      <a:tailEnd type="none" w="med" len="med"/>
+                    </a:lnR>
+                    <a:lnT w="9525" cap="flat" cmpd="sng" algn="ctr">
+                      <a:solidFill>
+                        <a:srgbClr val="BFBFBF"/>
+                      </a:solidFill>
+                      <a:prstDash val="solid"/>
+                      <a:round/>
+                      <a:headEnd type="none" w="med" len="med"/>
+                      <a:tailEnd type="none" w="med" len="med"/>
+                    </a:lnT>
+                    <a:lnB w="9525" cap="flat" cmpd="sng" algn="ctr">
+                      <a:solidFill>
+                        <a:srgbClr val="BFBFBF"/>
+                      </a:solidFill>
+                      <a:prstDash val="solid"/>
+                      <a:round/>
+                      <a:headEnd type="none" w="med" len="med"/>
+                      <a:tailEnd type="none" w="med" len="med"/>
+                    </a:lnB>
+                    <a:solidFill>
+                      <a:srgbClr val="F2F2F2"/>
+                    </a:solidFill>
+                  </a:tcPr>
+                </a:tc>
+              </a:tr>
+              <a:tr h="329184">
+                <a:tc>
+                  <a:txBody>
+                    <a:bodyPr/>
+                    <a:lstStyle/>
+                    <a:p>
+                      <a:pPr algn="l" indent="0" marL="0">
+                        <a:buNone/>
+                      </a:pPr>
+                      <a:r>
+                        <a:rPr lang="en-US" sz="1600" b="1" dirty="0">
+                          <a:solidFill>
+                            <a:schemeClr val="tx1"/>
+                          </a:solidFill>
+                        </a:rPr>
+                        <a:t>Push: đẩy thẳng vào Alertmanager</a:t>
+                      </a:r>
+                      <a:endParaRPr lang="en-US" sz="1600" dirty="0"/>
+                    </a:p>
+                  </a:txBody>
+                  <a:tcPr marL="76200" marR="76200" marT="38100" marB="38100" anchor="ctr">
+                    <a:lnL w="9525" cap="flat" cmpd="sng" algn="ctr">
+                      <a:solidFill>
+                        <a:srgbClr val="BFBFBF"/>
+                      </a:solidFill>
+                      <a:prstDash val="solid"/>
+                      <a:round/>
+                      <a:headEnd type="none" w="med" len="med"/>
+                      <a:tailEnd type="none" w="med" len="med"/>
+                    </a:lnL>
+                    <a:lnR w="9525" cap="flat" cmpd="sng" algn="ctr">
+                      <a:solidFill>
+                        <a:srgbClr val="BFBFBF"/>
+                      </a:solidFill>
+                      <a:prstDash val="solid"/>
+                      <a:round/>
+                      <a:headEnd type="none" w="med" len="med"/>
+                      <a:tailEnd type="none" w="med" len="med"/>
+                    </a:lnR>
+                    <a:lnT w="9525" cap="flat" cmpd="sng" algn="ctr">
+                      <a:solidFill>
+                        <a:srgbClr val="BFBFBF"/>
+                      </a:solidFill>
+                      <a:prstDash val="solid"/>
+                      <a:round/>
+                      <a:headEnd type="none" w="med" len="med"/>
+                      <a:tailEnd type="none" w="med" len="med"/>
+                    </a:lnT>
+                    <a:lnB w="9525" cap="flat" cmpd="sng" algn="ctr">
+                      <a:solidFill>
+                        <a:srgbClr val="BFBFBF"/>
+                      </a:solidFill>
+                      <a:prstDash val="solid"/>
+                      <a:round/>
+                      <a:headEnd type="none" w="med" len="med"/>
+                      <a:tailEnd type="none" w="med" len="med"/>
+                    </a:lnB>
+                  </a:tcPr>
+                </a:tc>
+                <a:tc>
+                  <a:txBody>
+                    <a:bodyPr/>
+                    <a:lstStyle/>
+                    <a:p>
+                      <a:pPr algn="r" indent="0" marL="0">
+                        <a:buNone/>
+                      </a:pPr>
+                      <a:r>
+                        <a:rPr lang="en-US" sz="1600" b="1" dirty="0">
+                          <a:solidFill>
+                            <a:schemeClr val="tx1"/>
+                          </a:solidFill>
+                        </a:rPr>
+                        <a:t>266/266 (100%)</a:t>
+                      </a:r>
+                      <a:endParaRPr lang="en-US" sz="1600" dirty="0"/>
+                    </a:p>
+                  </a:txBody>
+                  <a:tcPr marL="76200" marR="76200" marT="38100" marB="38100" anchor="ctr">
+                    <a:lnL w="9525" cap="flat" cmpd="sng" algn="ctr">
+                      <a:solidFill>
+                        <a:srgbClr val="BFBFBF"/>
+                      </a:solidFill>
+                      <a:prstDash val="solid"/>
+                      <a:round/>
+                      <a:headEnd type="none" w="med" len="med"/>
+                      <a:tailEnd type="none" w="med" len="med"/>
+                    </a:lnL>
+                    <a:lnR w="9525" cap="flat" cmpd="sng" algn="ctr">
+                      <a:solidFill>
+                        <a:srgbClr val="BFBFBF"/>
+                      </a:solidFill>
+                      <a:prstDash val="solid"/>
+                      <a:round/>
+                      <a:headEnd type="none" w="med" len="med"/>
+                      <a:tailEnd type="none" w="med" len="med"/>
+                    </a:lnR>
+                    <a:lnT w="9525" cap="flat" cmpd="sng" algn="ctr">
+                      <a:solidFill>
+                        <a:srgbClr val="BFBFBF"/>
+                      </a:solidFill>
+                      <a:prstDash val="solid"/>
+                      <a:round/>
+                      <a:headEnd type="none" w="med" len="med"/>
+                      <a:tailEnd type="none" w="med" len="med"/>
+                    </a:lnT>
+                    <a:lnB w="9525" cap="flat" cmpd="sng" algn="ctr">
+                      <a:solidFill>
+                        <a:srgbClr val="BFBFBF"/>
+                      </a:solidFill>
+                      <a:prstDash val="solid"/>
+                      <a:round/>
+                      <a:headEnd type="none" w="med" len="med"/>
+                      <a:tailEnd type="none" w="med" len="med"/>
+                    </a:lnB>
+                  </a:tcPr>
+                </a:tc>
+                <a:tc>
+                  <a:txBody>
+                    <a:bodyPr/>
+                    <a:lstStyle/>
+                    <a:p>
+                      <a:pPr algn="r" indent="0" marL="0">
+                        <a:buNone/>
+                      </a:pPr>
+                      <a:r>
+                        <a:rPr lang="en-US" sz="1600" b="1" dirty="0">
+                          <a:solidFill>
+                            <a:schemeClr val="tx1"/>
+                          </a:solidFill>
+                        </a:rPr>
+                        <a:t>0,03 s</a:t>
+                      </a:r>
+                      <a:endParaRPr lang="en-US" sz="1600" dirty="0"/>
+                    </a:p>
+                  </a:txBody>
+                  <a:tcPr marL="76200" marR="76200" marT="38100" marB="38100" anchor="ctr">
+                    <a:lnL w="9525" cap="flat" cmpd="sng" algn="ctr">
+                      <a:solidFill>
+                        <a:srgbClr val="BFBFBF"/>
+                      </a:solidFill>
+                      <a:prstDash val="solid"/>
+                      <a:round/>
+                      <a:headEnd type="none" w="med" len="med"/>
+                      <a:tailEnd type="none" w="med" len="med"/>
+                    </a:lnL>
+                    <a:lnR w="9525" cap="flat" cmpd="sng" algn="ctr">
+                      <a:solidFill>
+                        <a:srgbClr val="BFBFBF"/>
+                      </a:solidFill>
+                      <a:prstDash val="solid"/>
+                      <a:round/>
+                      <a:headEnd type="none" w="med" len="med"/>
+                      <a:tailEnd type="none" w="med" len="med"/>
+                    </a:lnR>
+                    <a:lnT w="9525" cap="flat" cmpd="sng" algn="ctr">
+                      <a:solidFill>
+                        <a:srgbClr val="BFBFBF"/>
+                      </a:solidFill>
+                      <a:prstDash val="solid"/>
+                      <a:round/>
+                      <a:headEnd type="none" w="med" len="med"/>
+                      <a:tailEnd type="none" w="med" len="med"/>
+                    </a:lnT>
+                    <a:lnB w="9525" cap="flat" cmpd="sng" algn="ctr">
+                      <a:solidFill>
+                        <a:srgbClr val="BFBFBF"/>
+                      </a:solidFill>
+                      <a:prstDash val="solid"/>
+                      <a:round/>
+                      <a:headEnd type="none" w="med" len="med"/>
+                      <a:tailEnd type="none" w="med" len="med"/>
+                    </a:lnB>
+                  </a:tcPr>
+                </a:tc>
+                <a:tc>
+                  <a:txBody>
+                    <a:bodyPr/>
+                    <a:lstStyle/>
+                    <a:p>
+                      <a:pPr algn="r" indent="0" marL="0">
+                        <a:buNone/>
+                      </a:pPr>
+                      <a:r>
+                        <a:rPr lang="en-US" sz="1600" b="1" dirty="0">
+                          <a:solidFill>
+                            <a:schemeClr val="tx1"/>
+                          </a:solidFill>
+                        </a:rPr>
+                        <a:t>0,06 s</a:t>
+                      </a:r>
+                      <a:endParaRPr lang="en-US" sz="1600" dirty="0"/>
+                    </a:p>
+                  </a:txBody>
+                  <a:tcPr marL="76200" marR="76200" marT="38100" marB="38100" anchor="ctr">
+                    <a:lnL w="9525" cap="flat" cmpd="sng" algn="ctr">
+                      <a:solidFill>
+                        <a:srgbClr val="BFBFBF"/>
+                      </a:solidFill>
+                      <a:prstDash val="solid"/>
+                      <a:round/>
+                      <a:headEnd type="none" w="med" len="med"/>
+                      <a:tailEnd type="none" w="med" len="med"/>
+                    </a:lnL>
+                    <a:lnR w="9525" cap="flat" cmpd="sng" algn="ctr">
+                      <a:solidFill>
+                        <a:srgbClr val="BFBFBF"/>
+                      </a:solidFill>
+                      <a:prstDash val="solid"/>
+                      <a:round/>
+                      <a:headEnd type="none" w="med" len="med"/>
+                      <a:tailEnd type="none" w="med" len="med"/>
+                    </a:lnR>
+                    <a:lnT w="9525" cap="flat" cmpd="sng" algn="ctr">
+                      <a:solidFill>
+                        <a:srgbClr val="BFBFBF"/>
+                      </a:solidFill>
+                      <a:prstDash val="solid"/>
+                      <a:round/>
+                      <a:headEnd type="none" w="med" len="med"/>
+                      <a:tailEnd type="none" w="med" len="med"/>
+                    </a:lnT>
+                    <a:lnB w="9525" cap="flat" cmpd="sng" algn="ctr">
+                      <a:solidFill>
+                        <a:srgbClr val="BFBFBF"/>
+                      </a:solidFill>
+                      <a:prstDash val="solid"/>
+                      <a:round/>
+                      <a:headEnd type="none" w="med" len="med"/>
+                      <a:tailEnd type="none" w="med" len="med"/>
+                    </a:lnB>
+                  </a:tcPr>
+                </a:tc>
+              </a:tr>
+              <a:tr h="329184">
+                <a:tc>
+                  <a:txBody>
+                    <a:bodyPr/>
+                    <a:lstStyle/>
+                    <a:p>
+                      <a:pPr algn="l" indent="0" marL="0">
+                        <a:buNone/>
+                      </a:pPr>
+                      <a:r>
+                        <a:rPr lang="en-US" sz="1600" dirty="0">
+                          <a:solidFill>
+                            <a:schemeClr val="tx1"/>
+                          </a:solidFill>
+                        </a:rPr>
+                        <a:t>Pull nhanh: scrape 5 s, rule 5 s</a:t>
+                      </a:r>
+                      <a:endParaRPr lang="en-US" sz="1600" dirty="0"/>
+                    </a:p>
+                  </a:txBody>
+                  <a:tcPr marL="76200" marR="76200" marT="38100" marB="38100" anchor="ctr">
+                    <a:lnL w="9525" cap="flat" cmpd="sng" algn="ctr">
+                      <a:solidFill>
+                        <a:srgbClr val="BFBFBF"/>
+                      </a:solidFill>
+                      <a:prstDash val="solid"/>
+                      <a:round/>
+                      <a:headEnd type="none" w="med" len="med"/>
+                      <a:tailEnd type="none" w="med" len="med"/>
+                    </a:lnL>
+                    <a:lnR w="9525" cap="flat" cmpd="sng" algn="ctr">
+                      <a:solidFill>
+                        <a:srgbClr val="BFBFBF"/>
+                      </a:solidFill>
+                      <a:prstDash val="solid"/>
+                      <a:round/>
+                      <a:headEnd type="none" w="med" len="med"/>
+                      <a:tailEnd type="none" w="med" len="med"/>
+                    </a:lnR>
+                    <a:lnT w="9525" cap="flat" cmpd="sng" algn="ctr">
+                      <a:solidFill>
+                        <a:srgbClr val="BFBFBF"/>
+                      </a:solidFill>
+                      <a:prstDash val="solid"/>
+                      <a:round/>
+                      <a:headEnd type="none" w="med" len="med"/>
+                      <a:tailEnd type="none" w="med" len="med"/>
+                    </a:lnT>
+                    <a:lnB w="9525" cap="flat" cmpd="sng" algn="ctr">
+                      <a:solidFill>
+                        <a:srgbClr val="BFBFBF"/>
+                      </a:solidFill>
+                      <a:prstDash val="solid"/>
+                      <a:round/>
+                      <a:headEnd type="none" w="med" len="med"/>
+                      <a:tailEnd type="none" w="med" len="med"/>
+                    </a:lnB>
+                  </a:tcPr>
+                </a:tc>
+                <a:tc>
+                  <a:txBody>
+                    <a:bodyPr/>
+                    <a:lstStyle/>
+                    <a:p>
+                      <a:pPr algn="r" indent="0" marL="0">
+                        <a:buNone/>
+                      </a:pPr>
+                      <a:r>
+                        <a:rPr lang="en-US" sz="1600" dirty="0">
+                          <a:solidFill>
+                            <a:schemeClr val="tx1"/>
+                          </a:solidFill>
+                        </a:rPr>
+                        <a:t>250/266 (94%)</a:t>
+                      </a:r>
+                      <a:endParaRPr lang="en-US" sz="1600" dirty="0"/>
+                    </a:p>
+                  </a:txBody>
+                  <a:tcPr marL="76200" marR="76200" marT="38100" marB="38100" anchor="ctr">
+                    <a:lnL w="9525" cap="flat" cmpd="sng" algn="ctr">
+                      <a:solidFill>
+                        <a:srgbClr val="BFBFBF"/>
+                      </a:solidFill>
+                      <a:prstDash val="solid"/>
+                      <a:round/>
+                      <a:headEnd type="none" w="med" len="med"/>
+                      <a:tailEnd type="none" w="med" len="med"/>
+                    </a:lnL>
+                    <a:lnR w="9525" cap="flat" cmpd="sng" algn="ctr">
+                      <a:solidFill>
+                        <a:srgbClr val="BFBFBF"/>
+                      </a:solidFill>
+                      <a:prstDash val="solid"/>
+                      <a:round/>
+                      <a:headEnd type="none" w="med" len="med"/>
+                      <a:tailEnd type="none" w="med" len="med"/>
+                    </a:lnR>
+                    <a:lnT w="9525" cap="flat" cmpd="sng" algn="ctr">
+                      <a:solidFill>
+                        <a:srgbClr val="BFBFBF"/>
+                      </a:solidFill>
+                      <a:prstDash val="solid"/>
+                      <a:round/>
+                      <a:headEnd type="none" w="med" len="med"/>
+                      <a:tailEnd type="none" w="med" len="med"/>
+                    </a:lnT>
+                    <a:lnB w="9525" cap="flat" cmpd="sng" algn="ctr">
+                      <a:solidFill>
+                        <a:srgbClr val="BFBFBF"/>
+                      </a:solidFill>
+                      <a:prstDash val="solid"/>
+                      <a:round/>
+                      <a:headEnd type="none" w="med" len="med"/>
+                      <a:tailEnd type="none" w="med" len="med"/>
+                    </a:lnB>
+                  </a:tcPr>
+                </a:tc>
+                <a:tc>
+                  <a:txBody>
+                    <a:bodyPr/>
+                    <a:lstStyle/>
+                    <a:p>
+                      <a:pPr algn="r" indent="0" marL="0">
+                        <a:buNone/>
+                      </a:pPr>
+                      <a:r>
+                        <a:rPr lang="en-US" sz="1600" dirty="0">
+                          <a:solidFill>
+                            <a:schemeClr val="tx1"/>
+                          </a:solidFill>
+                        </a:rPr>
+                        <a:t>4,6 s</a:t>
+                      </a:r>
+                      <a:endParaRPr lang="en-US" sz="1600" dirty="0"/>
+                    </a:p>
+                  </a:txBody>
+                  <a:tcPr marL="76200" marR="76200" marT="38100" marB="38100" anchor="ctr">
+                    <a:lnL w="9525" cap="flat" cmpd="sng" algn="ctr">
+                      <a:solidFill>
+                        <a:srgbClr val="BFBFBF"/>
+                      </a:solidFill>
+                      <a:prstDash val="solid"/>
+                      <a:round/>
+                      <a:headEnd type="none" w="med" len="med"/>
+                      <a:tailEnd type="none" w="med" len="med"/>
+                    </a:lnL>
+                    <a:lnR w="9525" cap="flat" cmpd="sng" algn="ctr">
+                      <a:solidFill>
+                        <a:srgbClr val="BFBFBF"/>
+                      </a:solidFill>
+                      <a:prstDash val="solid"/>
+                      <a:round/>
+                      <a:headEnd type="none" w="med" len="med"/>
+                      <a:tailEnd type="none" w="med" len="med"/>
+                    </a:lnR>
+                    <a:lnT w="9525" cap="flat" cmpd="sng" algn="ctr">
+                      <a:solidFill>
+                        <a:srgbClr val="BFBFBF"/>
+                      </a:solidFill>
+                      <a:prstDash val="solid"/>
+                      <a:round/>
+                      <a:headEnd type="none" w="med" len="med"/>
+                      <a:tailEnd type="none" w="med" len="med"/>
+                    </a:lnT>
+                    <a:lnB w="9525" cap="flat" cmpd="sng" algn="ctr">
+                      <a:solidFill>
+                        <a:srgbClr val="BFBFBF"/>
+                      </a:solidFill>
+                      <a:prstDash val="solid"/>
+                      <a:round/>
+                      <a:headEnd type="none" w="med" len="med"/>
+                      <a:tailEnd type="none" w="med" len="med"/>
+                    </a:lnB>
+                  </a:tcPr>
+                </a:tc>
+                <a:tc>
+                  <a:txBody>
+                    <a:bodyPr/>
+                    <a:lstStyle/>
+                    <a:p>
+                      <a:pPr algn="r" indent="0" marL="0">
+                        <a:buNone/>
+                      </a:pPr>
+                      <a:r>
+                        <a:rPr lang="en-US" sz="1600" dirty="0">
+                          <a:solidFill>
+                            <a:schemeClr val="tx1"/>
+                          </a:solidFill>
+                        </a:rPr>
+                        <a:t>7,4 s</a:t>
+                      </a:r>
+                      <a:endParaRPr lang="en-US" sz="1600" dirty="0"/>
+                    </a:p>
+                  </a:txBody>
+                  <a:tcPr marL="76200" marR="76200" marT="38100" marB="38100" anchor="ctr">
+                    <a:lnL w="9525" cap="flat" cmpd="sng" algn="ctr">
+                      <a:solidFill>
+                        <a:srgbClr val="BFBFBF"/>
+                      </a:solidFill>
+                      <a:prstDash val="solid"/>
+                      <a:round/>
+                      <a:headEnd type="none" w="med" len="med"/>
+                      <a:tailEnd type="none" w="med" len="med"/>
+                    </a:lnL>
+                    <a:lnR w="9525" cap="flat" cmpd="sng" algn="ctr">
+                      <a:solidFill>
+                        <a:srgbClr val="BFBFBF"/>
+                      </a:solidFill>
+                      <a:prstDash val="solid"/>
+                      <a:round/>
+                      <a:headEnd type="none" w="med" len="med"/>
+                      <a:tailEnd type="none" w="med" len="med"/>
+                    </a:lnR>
+                    <a:lnT w="9525" cap="flat" cmpd="sng" algn="ctr">
+                      <a:solidFill>
+                        <a:srgbClr val="BFBFBF"/>
+                      </a:solidFill>
+                      <a:prstDash val="solid"/>
+                      <a:round/>
+                      <a:headEnd type="none" w="med" len="med"/>
+                      <a:tailEnd type="none" w="med" len="med"/>
+                    </a:lnT>
+                    <a:lnB w="9525" cap="flat" cmpd="sng" algn="ctr">
+                      <a:solidFill>
+                        <a:srgbClr val="BFBFBF"/>
+                      </a:solidFill>
+                      <a:prstDash val="solid"/>
+                      <a:round/>
+                      <a:headEnd type="none" w="med" len="med"/>
+                      <a:tailEnd type="none" w="med" len="med"/>
+                    </a:lnB>
+                  </a:tcPr>
+                </a:tc>
+              </a:tr>
+              <a:tr h="329184">
+                <a:tc>
+                  <a:txBody>
+                    <a:bodyPr/>
+                    <a:lstStyle/>
+                    <a:p>
+                      <a:pPr algn="l" indent="0" marL="0">
+                        <a:buNone/>
+                      </a:pPr>
+                      <a:r>
+                        <a:rPr lang="en-US" sz="1600" dirty="0">
+                          <a:solidFill>
+                            <a:schemeClr val="tx1"/>
+                          </a:solidFill>
+                        </a:rPr>
+                        <a:t>Pull mặc định: scrape 30 s, rule 30 s, chờ gom 30 s</a:t>
+                      </a:r>
+                      <a:endParaRPr lang="en-US" sz="1600" dirty="0"/>
+                    </a:p>
+                  </a:txBody>
+                  <a:tcPr marL="76200" marR="76200" marT="38100" marB="38100" anchor="ctr">
+                    <a:lnL w="9525" cap="flat" cmpd="sng" algn="ctr">
+                      <a:solidFill>
+                        <a:srgbClr val="BFBFBF"/>
+                      </a:solidFill>
+                      <a:prstDash val="solid"/>
+                      <a:round/>
+                      <a:headEnd type="none" w="med" len="med"/>
+                      <a:tailEnd type="none" w="med" len="med"/>
+                    </a:lnL>
+                    <a:lnR w="9525" cap="flat" cmpd="sng" algn="ctr">
+                      <a:solidFill>
+                        <a:srgbClr val="BFBFBF"/>
+                      </a:solidFill>
+                      <a:prstDash val="solid"/>
+                      <a:round/>
+                      <a:headEnd type="none" w="med" len="med"/>
+                      <a:tailEnd type="none" w="med" len="med"/>
+                    </a:lnR>
+                    <a:lnT w="9525" cap="flat" cmpd="sng" algn="ctr">
+                      <a:solidFill>
+                        <a:srgbClr val="BFBFBF"/>
+                      </a:solidFill>
+                      <a:prstDash val="solid"/>
+                      <a:round/>
+                      <a:headEnd type="none" w="med" len="med"/>
+                      <a:tailEnd type="none" w="med" len="med"/>
+                    </a:lnT>
+                    <a:lnB w="9525" cap="flat" cmpd="sng" algn="ctr">
+                      <a:solidFill>
+                        <a:srgbClr val="BFBFBF"/>
+                      </a:solidFill>
+                      <a:prstDash val="solid"/>
+                      <a:round/>
+                      <a:headEnd type="none" w="med" len="med"/>
+                      <a:tailEnd type="none" w="med" len="med"/>
+                    </a:lnB>
+                  </a:tcPr>
+                </a:tc>
+                <a:tc>
+                  <a:txBody>
+                    <a:bodyPr/>
+                    <a:lstStyle/>
+                    <a:p>
+                      <a:pPr algn="r" indent="0" marL="0">
+                        <a:buNone/>
+                      </a:pPr>
+                      <a:r>
+                        <a:rPr lang="en-US" sz="1600" dirty="0">
+                          <a:solidFill>
+                            <a:schemeClr val="tx1"/>
+                          </a:solidFill>
+                        </a:rPr>
+                        <a:t>22/266 (8%)</a:t>
+                      </a:r>
+                      <a:endParaRPr lang="en-US" sz="1600" dirty="0"/>
+                    </a:p>
+                  </a:txBody>
+                  <a:tcPr marL="76200" marR="76200" marT="38100" marB="38100" anchor="ctr">
+                    <a:lnL w="9525" cap="flat" cmpd="sng" algn="ctr">
+                      <a:solidFill>
+                        <a:srgbClr val="BFBFBF"/>
+                      </a:solidFill>
+                      <a:prstDash val="solid"/>
+                      <a:round/>
+                      <a:headEnd type="none" w="med" len="med"/>
+                      <a:tailEnd type="none" w="med" len="med"/>
+                    </a:lnL>
+                    <a:lnR w="9525" cap="flat" cmpd="sng" algn="ctr">
+                      <a:solidFill>
+                        <a:srgbClr val="BFBFBF"/>
+                      </a:solidFill>
+                      <a:prstDash val="solid"/>
+                      <a:round/>
+                      <a:headEnd type="none" w="med" len="med"/>
+                      <a:tailEnd type="none" w="med" len="med"/>
+                    </a:lnR>
+                    <a:lnT w="9525" cap="flat" cmpd="sng" algn="ctr">
+                      <a:solidFill>
+                        <a:srgbClr val="BFBFBF"/>
+                      </a:solidFill>
+                      <a:prstDash val="solid"/>
+                      <a:round/>
+                      <a:headEnd type="none" w="med" len="med"/>
+                      <a:tailEnd type="none" w="med" len="med"/>
+                    </a:lnT>
+                    <a:lnB w="9525" cap="flat" cmpd="sng" algn="ctr">
+                      <a:solidFill>
+                        <a:srgbClr val="BFBFBF"/>
+                      </a:solidFill>
+                      <a:prstDash val="solid"/>
+                      <a:round/>
+                      <a:headEnd type="none" w="med" len="med"/>
+                      <a:tailEnd type="none" w="med" len="med"/>
+                    </a:lnB>
+                  </a:tcPr>
+                </a:tc>
+                <a:tc>
+                  <a:txBody>
+                    <a:bodyPr/>
+                    <a:lstStyle/>
+                    <a:p>
+                      <a:pPr algn="r" indent="0" marL="0">
+                        <a:buNone/>
+                      </a:pPr>
+                      <a:r>
+                        <a:rPr lang="en-US" sz="1600" dirty="0">
+                          <a:solidFill>
+                            <a:schemeClr val="tx1"/>
+                          </a:solidFill>
+                        </a:rPr>
+                        <a:t>52 s</a:t>
+                      </a:r>
+                      <a:endParaRPr lang="en-US" sz="1600" dirty="0"/>
+                    </a:p>
+                  </a:txBody>
+                  <a:tcPr marL="76200" marR="76200" marT="38100" marB="38100" anchor="ctr">
+                    <a:lnL w="9525" cap="flat" cmpd="sng" algn="ctr">
+                      <a:solidFill>
+                        <a:srgbClr val="BFBFBF"/>
+                      </a:solidFill>
+                      <a:prstDash val="solid"/>
+                      <a:round/>
+                      <a:headEnd type="none" w="med" len="med"/>
+                      <a:tailEnd type="none" w="med" len="med"/>
+                    </a:lnL>
+                    <a:lnR w="9525" cap="flat" cmpd="sng" algn="ctr">
+                      <a:solidFill>
+                        <a:srgbClr val="BFBFBF"/>
+                      </a:solidFill>
+                      <a:prstDash val="solid"/>
+                      <a:round/>
+                      <a:headEnd type="none" w="med" len="med"/>
+                      <a:tailEnd type="none" w="med" len="med"/>
+                    </a:lnR>
+                    <a:lnT w="9525" cap="flat" cmpd="sng" algn="ctr">
+                      <a:solidFill>
+                        <a:srgbClr val="BFBFBF"/>
+                      </a:solidFill>
+                      <a:prstDash val="solid"/>
+                      <a:round/>
+                      <a:headEnd type="none" w="med" len="med"/>
+                      <a:tailEnd type="none" w="med" len="med"/>
+                    </a:lnT>
+                    <a:lnB w="9525" cap="flat" cmpd="sng" algn="ctr">
+                      <a:solidFill>
+                        <a:srgbClr val="BFBFBF"/>
+                      </a:solidFill>
+                      <a:prstDash val="solid"/>
+                      <a:round/>
+                      <a:headEnd type="none" w="med" len="med"/>
+                      <a:tailEnd type="none" w="med" len="med"/>
+                    </a:lnB>
+                  </a:tcPr>
+                </a:tc>
+                <a:tc>
+                  <a:txBody>
+                    <a:bodyPr/>
+                    <a:lstStyle/>
+                    <a:p>
+                      <a:pPr algn="r" indent="0" marL="0">
+                        <a:buNone/>
+                      </a:pPr>
+                      <a:r>
+                        <a:rPr lang="en-US" sz="1600" dirty="0">
+                          <a:solidFill>
+                            <a:schemeClr val="tx1"/>
+                          </a:solidFill>
+                        </a:rPr>
+                        <a:t>63 s</a:t>
+                      </a:r>
+                      <a:endParaRPr lang="en-US" sz="1600" dirty="0"/>
+                    </a:p>
+                  </a:txBody>
+                  <a:tcPr marL="76200" marR="76200" marT="38100" marB="38100" anchor="ctr">
+                    <a:lnL w="9525" cap="flat" cmpd="sng" algn="ctr">
+                      <a:solidFill>
+                        <a:srgbClr val="BFBFBF"/>
+                      </a:solidFill>
+                      <a:prstDash val="solid"/>
+                      <a:round/>
+                      <a:headEnd type="none" w="med" len="med"/>
+                      <a:tailEnd type="none" w="med" len="med"/>
+                    </a:lnL>
+                    <a:lnR w="9525" cap="flat" cmpd="sng" algn="ctr">
+                      <a:solidFill>
+                        <a:srgbClr val="BFBFBF"/>
+                      </a:solidFill>
+                      <a:prstDash val="solid"/>
+                      <a:round/>
+                      <a:headEnd type="none" w="med" len="med"/>
+                      <a:tailEnd type="none" w="med" len="med"/>
+                    </a:lnR>
+                    <a:lnT w="9525" cap="flat" cmpd="sng" algn="ctr">
+                      <a:solidFill>
+                        <a:srgbClr val="BFBFBF"/>
+                      </a:solidFill>
+                      <a:prstDash val="solid"/>
+                      <a:round/>
+                      <a:headEnd type="none" w="med" len="med"/>
+                      <a:tailEnd type="none" w="med" len="med"/>
+                    </a:lnT>
+                    <a:lnB w="9525" cap="flat" cmpd="sng" algn="ctr">
+                      <a:solidFill>
+                        <a:srgbClr val="BFBFBF"/>
+                      </a:solidFill>
+                      <a:prstDash val="solid"/>
+                      <a:round/>
+                      <a:headEnd type="none" w="med" len="med"/>
+                      <a:tailEnd type="none" w="med" len="med"/>
+                    </a:lnB>
+                  </a:tcPr>
+                </a:tc>
+              </a:tr>
+            </a:tbl>
+          </a:graphicData>
+        </a:graphic>
+      </p:graphicFrame>
+      <p:sp>
+        <p:nvSpPr>
+          <p:cNvPr id="4" name="Ghi chú"/>
+          <p:cNvSpPr txBox="1"/>
+          <p:nvPr/>
+        </p:nvSpPr>
+        <p:spPr>
+          <a:xfrm>
+            <a:off x="813816" y="2514600"/>
+            <a:ext cx="10881360" cy="365760"/>
+          </a:xfrm>
+          <a:prstGeom prst="rect">
+            <a:avLst/>
+          </a:prstGeom>
+          <a:noFill/>
+          <a:ln/>
+        </p:spPr>
+        <p:txBody>
+          <a:bodyPr wrap="square" lIns="635" tIns="635" rIns="635" bIns="635" rtlCol="0" anchor="t"/>
+          <a:lstStyle/>
+          <a:p>
+            <a:pPr indent="0" marL="0">
+              <a:buNone/>
+            </a:pPr>
+            <a:r>
+              <a:rPr lang="en-US" sz="1200" dirty="0">
+                <a:solidFill>
+                  <a:schemeClr val="tx1"/>
+                </a:solidFill>
+              </a:rPr>
+              <a:t>Độ trễ từ lúc Pulse ghi preview tới lúc webhook nhận, các đợt đã kết thúc tới 04:16 ngày 23/10; đang thu tiếp tới hết lượt.</a:t>
+            </a:r>
+            <a:endParaRPr lang="en-US" sz="1200" dirty="0"/>
+          </a:p>
+        </p:txBody>
+      </p:sp>
+      <p:sp>
+        <p:nvSpPr>
+          <p:cNvPr id="5" name="Nội dung"/>
+          <p:cNvSpPr txBox="1"/>
+          <p:nvPr/>
+        </p:nvSpPr>
+        <p:spPr>
+          <a:xfrm>
+            <a:off x="813816" y="3017520"/>
+            <a:ext cx="10881360" cy="3291840"/>
+          </a:xfrm>
+          <a:prstGeom prst="rect">
+            <a:avLst/>
+          </a:prstGeom>
+          <a:noFill/>
+          <a:ln/>
+        </p:spPr>
+        <p:txBody>
+          <a:bodyPr wrap="square" lIns="635" tIns="635" rIns="635" bIns="635" rtlCol="0" anchor="t"/>
+          <a:lstStyle/>
+          <a:p>
+            <a:pPr marL="228600" indent="-228600">
+              <a:spcAft>
+                <a:spcPts val="1000"/>
+              </a:spcAft>
+              <a:buSzPct val="100000"/>
+              <a:buChar char="•"/>
+            </a:pPr>
+            <a:r>
+              <a:rPr lang="en-US" sz="1800" b="1" dirty="0">
+                <a:solidFill>
+                  <a:schemeClr val="tx1"/>
+                </a:solidFill>
+              </a:rPr>
+              <a:t>Cách thử: </a:t>
+            </a:r>
+            <a:r>
+              <a:rPr lang="en-US" sz="1800" dirty="0">
+                <a:solidFill>
+                  <a:schemeClr val="tx1"/>
+                </a:solidFill>
+              </a:rPr>
+              <a:t>bridge chỉ đọc decision của lượt xác nhận, gom preview thành đợt theo container; mỗi đợt mang mã case RCA nên cảnh báo trỏ thẳng tới cây bằng chứng</a:t>
+            </a:r>
+            <a:endParaRPr lang="en-US" sz="1800" dirty="0"/>
+          </a:p>
+          <a:p>
+            <a:pPr marL="228600" indent="-228600">
+              <a:spcAft>
+                <a:spcPts val="1000"/>
+              </a:spcAft>
+              <a:buSzPct val="100000"/>
+              <a:buChar char="•"/>
+            </a:pPr>
+            <a:r>
+              <a:rPr lang="en-US" sz="1800" b="1" dirty="0">
+                <a:solidFill>
+                  <a:schemeClr val="tx1"/>
+                </a:solidFill>
+              </a:rPr>
+              <a:t>Đọc: </a:t>
+            </a:r>
+            <a:r>
+              <a:rPr lang="en-US" sz="1800" dirty="0">
+                <a:solidFill>
+                  <a:schemeClr val="tx1"/>
+                </a:solidFill>
+              </a:rPr>
+              <a:t>đợt cảnh báo thường ngắn hơn chu kỳ của Prometheus → đường pull vừa chậm vừa lỡ; mặc định thì 92% đợt không tới người nhận</a:t>
+            </a:r>
+            <a:endParaRPr lang="en-US" sz="1800" dirty="0"/>
+          </a:p>
+          <a:p>
+            <a:pPr marL="228600" indent="-228600">
+              <a:spcAft>
+                <a:spcPts val="1000"/>
+              </a:spcAft>
+              <a:buSzPct val="100000"/>
+              <a:buChar char="•"/>
+            </a:pPr>
+            <a:r>
+              <a:rPr lang="en-US" sz="1800" b="1" dirty="0">
+                <a:solidFill>
+                  <a:schemeClr val="tx1"/>
+                </a:solidFill>
+              </a:rPr>
+              <a:t>Kernel → người nhận: </a:t>
+            </a:r>
+            <a:r>
+              <a:rPr lang="en-US" sz="1800" dirty="0">
+                <a:solidFill>
+                  <a:schemeClr val="tx1"/>
+                </a:solidFill>
+              </a:rPr>
+              <a:t>ước tính khoảng 2,1 s (preview p95 2,05 s + 0,06 s); số đo theo từng trial sau lượt xác nhận</a:t>
+            </a:r>
+            <a:endParaRPr lang="en-US" sz="1800" dirty="0"/>
+          </a:p>
+          <a:p>
+            <a:pPr marL="228600" indent="-228600">
+              <a:spcAft>
+                <a:spcPts val="1000"/>
+              </a:spcAft>
+              <a:buSzPct val="100000"/>
+              <a:buChar char="•"/>
+            </a:pPr>
+            <a:r>
+              <a:rPr lang="en-US" sz="1800" b="1" dirty="0">
+                <a:solidFill>
+                  <a:schemeClr val="tx1"/>
+                </a:solidFill>
+              </a:rPr>
+              <a:t>Grafana: </a:t>
+            </a:r>
+            <a:r>
+              <a:rPr lang="en-US" sz="1800" dirty="0">
+                <a:solidFill>
+                  <a:schemeClr val="tx1"/>
+                </a:solidFill>
+              </a:rPr>
+              <a:t>dashboard "Sentinel Pulse – cảnh báo vận hành": container đang cảnh báo, số đợt mỗi giờ, độ trễ theo đường</a:t>
+            </a:r>
+            <a:endParaRPr lang="en-US" sz="1800" dirty="0"/>
+          </a:p>
+        </p:txBody>
+      </p:sp>
+    </p:spTree>
+  </p:cSld>
+  <p:clrMapOvr>
+    <a:masterClrMapping/>
+  </p:clrMapOvr>
+</p:sld>
+</file>
+
+<file path=ppt/slides/slide13.xml><?xml version="1.0" encoding="utf-8"?>
+<p:sld xmlns:a="http://schemas.openxmlformats.org/drawingml/2006/main" xmlns:r="http://schemas.openxmlformats.org/officeDocument/2006/relationships" xmlns:p="http://schemas.openxmlformats.org/presentationml/2006/main">
+  <p:cSld name="Slide 13">
     <p:spTree>
       <p:nvGrpSpPr>
         <p:cNvPr id="1" name=""/>
@@ -6424,32 +7719,6 @@
             </a:r>
             <a:endParaRPr lang="en-US" sz="1800" dirty="0"/>
           </a:p>
-          <a:p>
-            <a:pPr marL="228600" indent="-228600">
-              <a:spcAft>
-                <a:spcPts val="1000"/>
-              </a:spcAft>
-              <a:buSzPct val="100000"/>
-              <a:buChar char="•"/>
-            </a:pPr>
-            <a:r>
-              <a:rPr lang="en-US" sz="1800" b="1" dirty="0">
-                <a:solidFill>
-                  <a:schemeClr val="tx1"/>
-                </a:solidFill>
-              </a:rPr>
-              <a:t>Khoảng tin cậy: </a:t>
-            </a:r>
-            <a:r>
-              <a:rPr lang="en-US" sz="1800" dirty="0">
-                <a:solidFill>
-                  <a:schemeClr val="tx1"/>
-                </a:solidFill>
-              </a:rPr>
-              <a:t>bootstrap ghép cặp theo workload, 10.000 lần</a:t>
-            </a:r>
-            <a:endParaRPr lang="en-US" sz="1800" dirty="0"/>
-          </a:p>
         </p:txBody>
       </p:sp>
     </p:spTree>
@@ -6460,9 +7729,9 @@
 </p:sld>
 </file>
 
-<file path=ppt/slides/slide13.xml><?xml version="1.0" encoding="utf-8"?>
+<file path=ppt/slides/slide14.xml><?xml version="1.0" encoding="utf-8"?>
 <p:sld xmlns:a="http://schemas.openxmlformats.org/drawingml/2006/main" xmlns:r="http://schemas.openxmlformats.org/officeDocument/2006/relationships" xmlns:p="http://schemas.openxmlformats.org/presentationml/2006/main">
-  <p:cSld name="Slide 13">
+  <p:cSld name="Slide 14">
     <p:spTree>
       <p:nvGrpSpPr>
         <p:cNvPr id="1" name=""/>
@@ -6517,7 +7786,7 @@
       </p:sp>
       <p:graphicFrame>
         <p:nvGraphicFramePr>
-          <p:cNvPr id="14" name="Bảng"/>
+          <p:cNvPr id="15" name="Bảng"/>
           <p:cNvGraphicFramePr>
             <a:graphicFrameLocks noGrp="1"/>
           </p:cNvGraphicFramePr>
@@ -6538,10 +7807,11 @@
             <a:tbl>
               <a:tblPr/>
               <a:tblGrid>
-                <a:gridCol w="3291840"/>
                 <a:gridCol w="3108960"/>
-                <a:gridCol w="3108960"/>
-                <a:gridCol w="1371600"/>
+                <a:gridCol w="2194560"/>
+                <a:gridCol w="2651760"/>
+                <a:gridCol w="1188720"/>
+                <a:gridCol w="1737360"/>
               </a:tblGrid>
               <a:tr h="329184">
                 <a:tc>
@@ -6619,7 +7889,7 @@
                             <a:schemeClr val="tx1"/>
                           </a:solidFill>
                         </a:rPr>
-                        <a:t>Chênh recall (CI 95%)</a:t>
+                        <a:t>Chênh recall</a:t>
                       </a:r>
                       <a:endParaRPr lang="en-US" sz="1600" dirty="0"/>
                     </a:p>
@@ -6788,6 +8058,67 @@
                     </a:solidFill>
                   </a:tcPr>
                 </a:tc>
+                <a:tc>
+                  <a:txBody>
+                    <a:bodyPr/>
+                    <a:lstStyle/>
+                    <a:p>
+                      <a:pPr algn="l" indent="0" marL="0">
+                        <a:buNone/>
+                      </a:pPr>
+                      <a:r>
+                        <a:rPr lang="en-US" sz="1600" b="1" dirty="0">
+                          <a:solidFill>
+                            <a:schemeClr val="tx1"/>
+                          </a:solidFill>
+                        </a:rPr>
+                        <a:t>Đọc</a:t>
+                      </a:r>
+                      <a:endParaRPr lang="en-US" sz="1600" dirty="0"/>
+                    </a:p>
+                  </a:txBody>
+                  <a:tcPr marL="76200" marR="76200" marT="38100" marB="38100" anchor="ctr">
+                    <a:lnL w="9525" cap="flat" cmpd="sng" algn="ctr">
+                      <a:solidFill>
+                        <a:srgbClr val="BFBFBF"/>
+                      </a:solidFill>
+                      <a:prstDash val="solid"/>
+                      <a:round/>
+                      <a:headEnd type="none" w="med" len="med"/>
+                      <a:tailEnd type="none" w="med" len="med"/>
+                    </a:lnL>
+                    <a:lnR w="9525" cap="flat" cmpd="sng" algn="ctr">
+                      <a:solidFill>
+                        <a:srgbClr val="BFBFBF"/>
+                      </a:solidFill>
+                      <a:prstDash val="solid"/>
+                      <a:round/>
+                      <a:headEnd type="none" w="med" len="med"/>
+                      <a:tailEnd type="none" w="med" len="med"/>
+                    </a:lnR>
+                    <a:lnT w="9525" cap="flat" cmpd="sng" algn="ctr">
+                      <a:solidFill>
+                        <a:srgbClr val="BFBFBF"/>
+                      </a:solidFill>
+                      <a:prstDash val="solid"/>
+                      <a:round/>
+                      <a:headEnd type="none" w="med" len="med"/>
+                      <a:tailEnd type="none" w="med" len="med"/>
+                    </a:lnT>
+                    <a:lnB w="9525" cap="flat" cmpd="sng" algn="ctr">
+                      <a:solidFill>
+                        <a:srgbClr val="BFBFBF"/>
+                      </a:solidFill>
+                      <a:prstDash val="solid"/>
+                      <a:round/>
+                      <a:headEnd type="none" w="med" len="med"/>
+                      <a:tailEnd type="none" w="med" len="med"/>
+                    </a:lnB>
+                    <a:solidFill>
+                      <a:srgbClr val="F2F2F2"/>
+                    </a:solidFill>
+                  </a:tcPr>
+                </a:tc>
               </a:tr>
               <a:tr h="329184">
                 <a:tc>
@@ -7022,6 +8353,64 @@
                     </a:lnB>
                   </a:tcPr>
                 </a:tc>
+                <a:tc>
+                  <a:txBody>
+                    <a:bodyPr/>
+                    <a:lstStyle/>
+                    <a:p>
+                      <a:pPr algn="l" indent="0" marL="0">
+                        <a:buNone/>
+                      </a:pPr>
+                      <a:r>
+                        <a:rPr lang="en-US" sz="1600" dirty="0">
+                          <a:solidFill>
+                            <a:schemeClr val="tx1"/>
+                          </a:solidFill>
+                        </a:rPr>
+                        <a:t>mốc</a:t>
+                      </a:r>
+                      <a:endParaRPr lang="en-US" sz="1600" dirty="0"/>
+                    </a:p>
+                  </a:txBody>
+                  <a:tcPr marL="76200" marR="76200" marT="38100" marB="38100" anchor="ctr">
+                    <a:lnL w="9525" cap="flat" cmpd="sng" algn="ctr">
+                      <a:solidFill>
+                        <a:srgbClr val="BFBFBF"/>
+                      </a:solidFill>
+                      <a:prstDash val="solid"/>
+                      <a:round/>
+                      <a:headEnd type="none" w="med" len="med"/>
+                      <a:tailEnd type="none" w="med" len="med"/>
+                    </a:lnL>
+                    <a:lnR w="9525" cap="flat" cmpd="sng" algn="ctr">
+                      <a:solidFill>
+                        <a:srgbClr val="BFBFBF"/>
+                      </a:solidFill>
+                      <a:prstDash val="solid"/>
+                      <a:round/>
+                      <a:headEnd type="none" w="med" len="med"/>
+                      <a:tailEnd type="none" w="med" len="med"/>
+                    </a:lnR>
+                    <a:lnT w="9525" cap="flat" cmpd="sng" algn="ctr">
+                      <a:solidFill>
+                        <a:srgbClr val="BFBFBF"/>
+                      </a:solidFill>
+                      <a:prstDash val="solid"/>
+                      <a:round/>
+                      <a:headEnd type="none" w="med" len="med"/>
+                      <a:tailEnd type="none" w="med" len="med"/>
+                    </a:lnT>
+                    <a:lnB w="9525" cap="flat" cmpd="sng" algn="ctr">
+                      <a:solidFill>
+                        <a:srgbClr val="BFBFBF"/>
+                      </a:solidFill>
+                      <a:prstDash val="solid"/>
+                      <a:round/>
+                      <a:headEnd type="none" w="med" len="med"/>
+                      <a:tailEnd type="none" w="med" len="med"/>
+                    </a:lnB>
+                  </a:tcPr>
+                </a:tc>
               </a:tr>
               <a:tr h="329184">
                 <a:tc>
@@ -7096,7 +8485,7 @@
                             <a:schemeClr val="tx1"/>
                           </a:solidFill>
                         </a:rPr>
-                        <a:t>−6,8 [−11,4; −2,4]</a:t>
+                        <a:t>−6,8 điểm</a:t>
                       </a:r>
                       <a:endParaRPr lang="en-US" sz="1600" dirty="0"/>
                     </a:p>
@@ -7154,7 +8543,7 @@
                             <a:schemeClr val="tx1"/>
                           </a:solidFill>
                         </a:rPr>
-                        <a:t>−5,2 [−8,9; −1,6]</a:t>
+                        <a:t>−5,2 điểm</a:t>
                       </a:r>
                       <a:endParaRPr lang="en-US" sz="1600" dirty="0"/>
                     </a:p>
@@ -7213,6 +8602,64 @@
                           </a:solidFill>
                         </a:rPr>
                         <a:t>7,72 s</a:t>
+                      </a:r>
+                      <a:endParaRPr lang="en-US" sz="1600" dirty="0"/>
+                    </a:p>
+                  </a:txBody>
+                  <a:tcPr marL="76200" marR="76200" marT="38100" marB="38100" anchor="ctr">
+                    <a:lnL w="9525" cap="flat" cmpd="sng" algn="ctr">
+                      <a:solidFill>
+                        <a:srgbClr val="BFBFBF"/>
+                      </a:solidFill>
+                      <a:prstDash val="solid"/>
+                      <a:round/>
+                      <a:headEnd type="none" w="med" len="med"/>
+                      <a:tailEnd type="none" w="med" len="med"/>
+                    </a:lnL>
+                    <a:lnR w="9525" cap="flat" cmpd="sng" algn="ctr">
+                      <a:solidFill>
+                        <a:srgbClr val="BFBFBF"/>
+                      </a:solidFill>
+                      <a:prstDash val="solid"/>
+                      <a:round/>
+                      <a:headEnd type="none" w="med" len="med"/>
+                      <a:tailEnd type="none" w="med" len="med"/>
+                    </a:lnR>
+                    <a:lnT w="9525" cap="flat" cmpd="sng" algn="ctr">
+                      <a:solidFill>
+                        <a:srgbClr val="BFBFBF"/>
+                      </a:solidFill>
+                      <a:prstDash val="solid"/>
+                      <a:round/>
+                      <a:headEnd type="none" w="med" len="med"/>
+                      <a:tailEnd type="none" w="med" len="med"/>
+                    </a:lnT>
+                    <a:lnB w="9525" cap="flat" cmpd="sng" algn="ctr">
+                      <a:solidFill>
+                        <a:srgbClr val="BFBFBF"/>
+                      </a:solidFill>
+                      <a:prstDash val="solid"/>
+                      <a:round/>
+                      <a:headEnd type="none" w="med" len="med"/>
+                      <a:tailEnd type="none" w="med" len="med"/>
+                    </a:lnB>
+                  </a:tcPr>
+                </a:tc>
+                <a:tc>
+                  <a:txBody>
+                    <a:bodyPr/>
+                    <a:lstStyle/>
+                    <a:p>
+                      <a:pPr algn="l" indent="0" marL="0">
+                        <a:buNone/>
+                      </a:pPr>
+                      <a:r>
+                        <a:rPr lang="en-US" sz="1600" dirty="0">
+                          <a:solidFill>
+                            <a:schemeClr val="tx1"/>
+                          </a:solidFill>
+                        </a:rPr>
+                        <a:t>kém hơn</a:t>
                       </a:r>
                       <a:endParaRPr lang="en-US" sz="1600" dirty="0"/>
                     </a:p>
@@ -7330,7 +8777,7 @@
                             <a:schemeClr val="tx1"/>
                           </a:solidFill>
                         </a:rPr>
-                        <a:t>+2,4 [+0,1; +6,4]</a:t>
+                        <a:t>+2,4 điểm</a:t>
                       </a:r>
                       <a:endParaRPr lang="en-US" sz="1600" dirty="0"/>
                     </a:p>
@@ -7388,7 +8835,7 @@
                             <a:schemeClr val="tx1"/>
                           </a:solidFill>
                         </a:rPr>
-                        <a:t>−21,8 [−36,7; −7,4]</a:t>
+                        <a:t>−21,8 điểm</a:t>
                       </a:r>
                       <a:endParaRPr lang="en-US" sz="1600" dirty="0"/>
                     </a:p>
@@ -7447,6 +8894,64 @@
                           </a:solidFill>
                         </a:rPr>
                         <a:t>0,82 s</a:t>
+                      </a:r>
+                      <a:endParaRPr lang="en-US" sz="1600" dirty="0"/>
+                    </a:p>
+                  </a:txBody>
+                  <a:tcPr marL="76200" marR="76200" marT="38100" marB="38100" anchor="ctr">
+                    <a:lnL w="9525" cap="flat" cmpd="sng" algn="ctr">
+                      <a:solidFill>
+                        <a:srgbClr val="BFBFBF"/>
+                      </a:solidFill>
+                      <a:prstDash val="solid"/>
+                      <a:round/>
+                      <a:headEnd type="none" w="med" len="med"/>
+                      <a:tailEnd type="none" w="med" len="med"/>
+                    </a:lnL>
+                    <a:lnR w="9525" cap="flat" cmpd="sng" algn="ctr">
+                      <a:solidFill>
+                        <a:srgbClr val="BFBFBF"/>
+                      </a:solidFill>
+                      <a:prstDash val="solid"/>
+                      <a:round/>
+                      <a:headEnd type="none" w="med" len="med"/>
+                      <a:tailEnd type="none" w="med" len="med"/>
+                    </a:lnR>
+                    <a:lnT w="9525" cap="flat" cmpd="sng" algn="ctr">
+                      <a:solidFill>
+                        <a:srgbClr val="BFBFBF"/>
+                      </a:solidFill>
+                      <a:prstDash val="solid"/>
+                      <a:round/>
+                      <a:headEnd type="none" w="med" len="med"/>
+                      <a:tailEnd type="none" w="med" len="med"/>
+                    </a:lnT>
+                    <a:lnB w="9525" cap="flat" cmpd="sng" algn="ctr">
+                      <a:solidFill>
+                        <a:srgbClr val="BFBFBF"/>
+                      </a:solidFill>
+                      <a:prstDash val="solid"/>
+                      <a:round/>
+                      <a:headEnd type="none" w="med" len="med"/>
+                      <a:tailEnd type="none" w="med" len="med"/>
+                    </a:lnB>
+                  </a:tcPr>
+                </a:tc>
+                <a:tc>
+                  <a:txBody>
+                    <a:bodyPr/>
+                    <a:lstStyle/>
+                    <a:p>
+                      <a:pPr algn="l" indent="0" marL="0">
+                        <a:buNone/>
+                      </a:pPr>
+                      <a:r>
+                        <a:rPr lang="en-US" sz="1600" dirty="0">
+                          <a:solidFill>
+                            <a:schemeClr val="tx1"/>
+                          </a:solidFill>
+                        </a:rPr>
+                        <a:t>tách kém hẳn</a:t>
                       </a:r>
                       <a:endParaRPr lang="en-US" sz="1600" dirty="0"/>
                     </a:p>
@@ -7564,7 +9069,7 @@
                             <a:schemeClr val="tx1"/>
                           </a:solidFill>
                         </a:rPr>
-                        <a:t>−1,1 / −1,4 / −3,8 (CI dưới 0)</a:t>
+                        <a:t>−1,1 / −1,4 / −3,8</a:t>
                       </a:r>
                       <a:endParaRPr lang="en-US" sz="1600" dirty="0"/>
                     </a:p>
@@ -7681,6 +9186,64 @@
                           </a:solidFill>
                         </a:rPr>
                         <a:t>6,7–7,4 s</a:t>
+                      </a:r>
+                      <a:endParaRPr lang="en-US" sz="1600" dirty="0"/>
+                    </a:p>
+                  </a:txBody>
+                  <a:tcPr marL="76200" marR="76200" marT="38100" marB="38100" anchor="ctr">
+                    <a:lnL w="9525" cap="flat" cmpd="sng" algn="ctr">
+                      <a:solidFill>
+                        <a:srgbClr val="BFBFBF"/>
+                      </a:solidFill>
+                      <a:prstDash val="solid"/>
+                      <a:round/>
+                      <a:headEnd type="none" w="med" len="med"/>
+                      <a:tailEnd type="none" w="med" len="med"/>
+                    </a:lnL>
+                    <a:lnR w="9525" cap="flat" cmpd="sng" algn="ctr">
+                      <a:solidFill>
+                        <a:srgbClr val="BFBFBF"/>
+                      </a:solidFill>
+                      <a:prstDash val="solid"/>
+                      <a:round/>
+                      <a:headEnd type="none" w="med" len="med"/>
+                      <a:tailEnd type="none" w="med" len="med"/>
+                    </a:lnR>
+                    <a:lnT w="9525" cap="flat" cmpd="sng" algn="ctr">
+                      <a:solidFill>
+                        <a:srgbClr val="BFBFBF"/>
+                      </a:solidFill>
+                      <a:prstDash val="solid"/>
+                      <a:round/>
+                      <a:headEnd type="none" w="med" len="med"/>
+                      <a:tailEnd type="none" w="med" len="med"/>
+                    </a:lnT>
+                    <a:lnB w="9525" cap="flat" cmpd="sng" algn="ctr">
+                      <a:solidFill>
+                        <a:srgbClr val="BFBFBF"/>
+                      </a:solidFill>
+                      <a:prstDash val="solid"/>
+                      <a:round/>
+                      <a:headEnd type="none" w="med" len="med"/>
+                      <a:tailEnd type="none" w="med" len="med"/>
+                    </a:lnB>
+                  </a:tcPr>
+                </a:tc>
+                <a:tc>
+                  <a:txBody>
+                    <a:bodyPr/>
+                    <a:lstStyle/>
+                    <a:p>
+                      <a:pPr algn="l" indent="0" marL="0">
+                        <a:buNone/>
+                      </a:pPr>
+                      <a:r>
+                        <a:rPr lang="en-US" sz="1600" dirty="0">
+                          <a:solidFill>
+                            <a:schemeClr val="tx1"/>
+                          </a:solidFill>
+                        </a:rPr>
+                        <a:t>kém hơn chút</a:t>
                       </a:r>
                       <a:endParaRPr lang="en-US" sz="1600" dirty="0"/>
                     </a:p>
@@ -7915,6 +9478,64 @@
                           </a:solidFill>
                         </a:rPr>
                         <a:t>5,7–7,3 s</a:t>
+                      </a:r>
+                      <a:endParaRPr lang="en-US" sz="1600" dirty="0"/>
+                    </a:p>
+                  </a:txBody>
+                  <a:tcPr marL="76200" marR="76200" marT="38100" marB="38100" anchor="ctr">
+                    <a:lnL w="9525" cap="flat" cmpd="sng" algn="ctr">
+                      <a:solidFill>
+                        <a:srgbClr val="BFBFBF"/>
+                      </a:solidFill>
+                      <a:prstDash val="solid"/>
+                      <a:round/>
+                      <a:headEnd type="none" w="med" len="med"/>
+                      <a:tailEnd type="none" w="med" len="med"/>
+                    </a:lnL>
+                    <a:lnR w="9525" cap="flat" cmpd="sng" algn="ctr">
+                      <a:solidFill>
+                        <a:srgbClr val="BFBFBF"/>
+                      </a:solidFill>
+                      <a:prstDash val="solid"/>
+                      <a:round/>
+                      <a:headEnd type="none" w="med" len="med"/>
+                      <a:tailEnd type="none" w="med" len="med"/>
+                    </a:lnR>
+                    <a:lnT w="9525" cap="flat" cmpd="sng" algn="ctr">
+                      <a:solidFill>
+                        <a:srgbClr val="BFBFBF"/>
+                      </a:solidFill>
+                      <a:prstDash val="solid"/>
+                      <a:round/>
+                      <a:headEnd type="none" w="med" len="med"/>
+                      <a:tailEnd type="none" w="med" len="med"/>
+                    </a:lnT>
+                    <a:lnB w="9525" cap="flat" cmpd="sng" algn="ctr">
+                      <a:solidFill>
+                        <a:srgbClr val="BFBFBF"/>
+                      </a:solidFill>
+                      <a:prstDash val="solid"/>
+                      <a:round/>
+                      <a:headEnd type="none" w="med" len="med"/>
+                      <a:tailEnd type="none" w="med" len="med"/>
+                    </a:lnB>
+                  </a:tcPr>
+                </a:tc>
+                <a:tc>
+                  <a:txBody>
+                    <a:bodyPr/>
+                    <a:lstStyle/>
+                    <a:p>
+                      <a:pPr algn="l" indent="0" marL="0">
+                        <a:buNone/>
+                      </a:pPr>
+                      <a:r>
+                        <a:rPr lang="en-US" sz="1600" dirty="0">
+                          <a:solidFill>
+                            <a:schemeClr val="tx1"/>
+                          </a:solidFill>
+                        </a:rPr>
+                        <a:t>không khác</a:t>
                       </a:r>
                       <a:endParaRPr lang="en-US" sz="1600" dirty="0"/>
                     </a:p>
@@ -7971,8 +9592,8 @@
         </p:nvSpPr>
         <p:spPr>
           <a:xfrm>
-            <a:off x="813816" y="3246120"/>
-            <a:ext cx="10881360" cy="3017520"/>
+            <a:off x="813816" y="3474720"/>
+            <a:ext cx="10881360" cy="2834640"/>
           </a:xfrm>
           <a:prstGeom prst="rect">
             <a:avLst/>
@@ -8071,9 +9692,9 @@
 </p:sld>
 </file>
 
-<file path=ppt/slides/slide14.xml><?xml version="1.0" encoding="utf-8"?>
+<file path=ppt/slides/slide15.xml><?xml version="1.0" encoding="utf-8"?>
 <p:sld xmlns:a="http://schemas.openxmlformats.org/drawingml/2006/main" xmlns:r="http://schemas.openxmlformats.org/officeDocument/2006/relationships" xmlns:p="http://schemas.openxmlformats.org/presentationml/2006/main">
-  <p:cSld name="Slide 14">
+  <p:cSld name="Slide 15">
     <p:spTree>
       <p:nvGrpSpPr>
         <p:cNvPr id="1" name=""/>
@@ -8128,7 +9749,7 @@
       </p:sp>
       <p:graphicFrame>
         <p:nvGraphicFramePr>
-          <p:cNvPr id="15" name="Bảng"/>
+          <p:cNvPr id="16" name="Bảng"/>
           <p:cNvGraphicFramePr>
             <a:graphicFrameLocks noGrp="1"/>
           </p:cNvGraphicFramePr>
@@ -9920,7 +11541,7 @@
                   <a:schemeClr val="tx1"/>
                 </a:solidFill>
               </a:rPr>
-              <a:t>Đang chạy: </a:t>
+              <a:t>Dưới CUSUM chặn trần (xong 23/10): </a:t>
             </a:r>
             <a:r>
               <a:rPr lang="en-US" sz="1800" dirty="0">
@@ -9928,7 +11549,7 @@
                   <a:schemeClr val="tx1"/>
                 </a:solidFill>
               </a:rPr>
-              <a:t>nhóm feature dưới CUSUM chặn trần</a:t>
+              <a:t>không thành phần nào đổi kết luận; bộ feature giữ nguyên</a:t>
             </a:r>
             <a:endParaRPr lang="en-US" sz="1800" dirty="0"/>
           </a:p>
@@ -9942,9 +11563,9 @@
 </p:sld>
 </file>
 
-<file path=ppt/slides/slide15.xml><?xml version="1.0" encoding="utf-8"?>
+<file path=ppt/slides/slide16.xml><?xml version="1.0" encoding="utf-8"?>
 <p:sld xmlns:a="http://schemas.openxmlformats.org/drawingml/2006/main" xmlns:r="http://schemas.openxmlformats.org/officeDocument/2006/relationships" xmlns:p="http://schemas.openxmlformats.org/presentationml/2006/main">
-  <p:cSld name="Slide 15">
+  <p:cSld name="Slide 16">
     <p:spTree>
       <p:nvGrpSpPr>
         <p:cNvPr id="1" name=""/>
@@ -9999,7 +11620,7 @@
       </p:sp>
       <p:graphicFrame>
         <p:nvGraphicFramePr>
-          <p:cNvPr id="16" name="Bảng"/>
+          <p:cNvPr id="17" name="Bảng"/>
           <p:cNvGraphicFramePr>
             <a:graphicFrameLocks noGrp="1"/>
           </p:cNvGraphicFramePr>
@@ -11025,9 +12646,9 @@
 </p:sld>
 </file>
 
-<file path=ppt/slides/slide16.xml><?xml version="1.0" encoding="utf-8"?>
+<file path=ppt/slides/slide17.xml><?xml version="1.0" encoding="utf-8"?>
 <p:sld xmlns:a="http://schemas.openxmlformats.org/drawingml/2006/main" xmlns:r="http://schemas.openxmlformats.org/officeDocument/2006/relationships" xmlns:p="http://schemas.openxmlformats.org/presentationml/2006/main">
-  <p:cSld name="Slide 16">
+  <p:cSld name="Slide 17">
     <p:spTree>
       <p:nvGrpSpPr>
         <p:cNvPr id="1" name=""/>
@@ -11218,6 +12839,32 @@
                   <a:schemeClr val="tx1"/>
                 </a:solidFill>
               </a:rPr>
+              <a:t>Ánh xạ IP (sửa 23/10): </a:t>
+            </a:r>
+            <a:r>
+              <a:rPr lang="en-US" sz="1800" dirty="0">
+                <a:solidFill>
+                  <a:schemeClr val="tx1"/>
+                </a:solidFill>
+              </a:rPr>
+              <a:t>IP node bị ghi thành pod node-exporter ở 75% case → nay là "Node, không xác định"; mesh Istio ambient che client thật sau waypoint</a:t>
+            </a:r>
+            <a:endParaRPr lang="en-US" sz="1800" dirty="0"/>
+          </a:p>
+          <a:p>
+            <a:pPr marL="228600" indent="-228600">
+              <a:spcAft>
+                <a:spcPts val="1000"/>
+              </a:spcAft>
+              <a:buSzPct val="100000"/>
+              <a:buChar char="•"/>
+            </a:pPr>
+            <a:r>
+              <a:rPr lang="en-US" sz="1800" b="1" dirty="0">
+                <a:solidFill>
+                  <a:schemeClr val="tx1"/>
+                </a:solidFill>
+              </a:rPr>
               <a:t>Giới hạn: </a:t>
             </a:r>
             <a:r>
@@ -11240,9 +12887,9 @@
 </p:sld>
 </file>
 
-<file path=ppt/slides/slide17.xml><?xml version="1.0" encoding="utf-8"?>
+<file path=ppt/slides/slide18.xml><?xml version="1.0" encoding="utf-8"?>
 <p:sld xmlns:a="http://schemas.openxmlformats.org/drawingml/2006/main" xmlns:r="http://schemas.openxmlformats.org/officeDocument/2006/relationships" xmlns:p="http://schemas.openxmlformats.org/presentationml/2006/main">
-  <p:cSld name="Slide 17">
+  <p:cSld name="Slide 18">
     <p:spTree>
       <p:nvGrpSpPr>
         <p:cNvPr id="1" name=""/>
@@ -11297,7 +12944,7 @@
       </p:sp>
       <p:graphicFrame>
         <p:nvGraphicFramePr>
-          <p:cNvPr id="18" name="Bảng"/>
+          <p:cNvPr id="19" name="Bảng"/>
           <p:cNvGraphicFramePr>
             <a:graphicFrameLocks noGrp="1"/>
           </p:cNvGraphicFramePr>
@@ -12855,9 +14502,9 @@
 </p:sld>
 </file>
 
-<file path=ppt/slides/slide18.xml><?xml version="1.0" encoding="utf-8"?>
+<file path=ppt/slides/slide19.xml><?xml version="1.0" encoding="utf-8"?>
 <p:sld xmlns:a="http://schemas.openxmlformats.org/drawingml/2006/main" xmlns:r="http://schemas.openxmlformats.org/officeDocument/2006/relationships" xmlns:p="http://schemas.openxmlformats.org/presentationml/2006/main">
-  <p:cSld name="Slide 18">
+  <p:cSld name="Slide 19">
     <p:spTree>
       <p:nvGrpSpPr>
         <p:cNvPr id="1" name=""/>
@@ -12904,1120 +14551,22 @@
                   <a:schemeClr val="tx1"/>
                 </a:solidFill>
               </a:rPr>
-              <a:t>Việc tiếp theo và tiến độ</a:t>
+              <a:t>Việc tiếp theo</a:t>
             </a:r>
             <a:endParaRPr lang="en-US" sz="2200" dirty="0"/>
           </a:p>
         </p:txBody>
       </p:sp>
-      <p:graphicFrame>
-        <p:nvGraphicFramePr>
-          <p:cNvPr id="19" name="Bảng"/>
-          <p:cNvGraphicFramePr>
-            <a:graphicFrameLocks noGrp="1"/>
-          </p:cNvGraphicFramePr>
-          <p:nvPr>
-            <p:extLst>
-              <p:ext uri="{D42A27DB-BD31-4B8C-83A1-F6EECF244321}">
-                <p14:modId xmlns:p14="http://schemas.microsoft.com/office/powerpoint/2010/main" val="1579011935"/>
-              </p:ext>
-            </p:extLst>
-          </p:nvPr>
-        </p:nvGraphicFramePr>
-        <p:xfrm>
-          <a:off x="813816" y="1024128"/>
-          <a:ext cx="4572000" cy="914400"/>
-        </p:xfrm>
-        <a:graphic>
-          <a:graphicData uri="http://schemas.openxmlformats.org/drawingml/2006/table">
-            <a:tbl>
-              <a:tblPr/>
-              <a:tblGrid>
-                <a:gridCol w="3474720"/>
-                <a:gridCol w="1097280"/>
-              </a:tblGrid>
-              <a:tr h="310896">
-                <a:tc>
-                  <a:txBody>
-                    <a:bodyPr/>
-                    <a:lstStyle/>
-                    <a:p>
-                      <a:pPr algn="l" indent="0" marL="0">
-                        <a:buNone/>
-                      </a:pPr>
-                      <a:r>
-                        <a:rPr lang="en-US" sz="1600" b="1" dirty="0">
-                          <a:solidFill>
-                            <a:schemeClr val="tx1"/>
-                          </a:solidFill>
-                        </a:rPr>
-                        <a:t>Hạng mục</a:t>
-                      </a:r>
-                      <a:endParaRPr lang="en-US" sz="1600" dirty="0"/>
-                    </a:p>
-                  </a:txBody>
-                  <a:tcPr marL="76200" marR="76200" marT="38100" marB="38100" anchor="ctr">
-                    <a:lnL w="9525" cap="flat" cmpd="sng" algn="ctr">
-                      <a:solidFill>
-                        <a:srgbClr val="BFBFBF"/>
-                      </a:solidFill>
-                      <a:prstDash val="solid"/>
-                      <a:round/>
-                      <a:headEnd type="none" w="med" len="med"/>
-                      <a:tailEnd type="none" w="med" len="med"/>
-                    </a:lnL>
-                    <a:lnR w="9525" cap="flat" cmpd="sng" algn="ctr">
-                      <a:solidFill>
-                        <a:srgbClr val="BFBFBF"/>
-                      </a:solidFill>
-                      <a:prstDash val="solid"/>
-                      <a:round/>
-                      <a:headEnd type="none" w="med" len="med"/>
-                      <a:tailEnd type="none" w="med" len="med"/>
-                    </a:lnR>
-                    <a:lnT w="9525" cap="flat" cmpd="sng" algn="ctr">
-                      <a:solidFill>
-                        <a:srgbClr val="BFBFBF"/>
-                      </a:solidFill>
-                      <a:prstDash val="solid"/>
-                      <a:round/>
-                      <a:headEnd type="none" w="med" len="med"/>
-                      <a:tailEnd type="none" w="med" len="med"/>
-                    </a:lnT>
-                    <a:lnB w="9525" cap="flat" cmpd="sng" algn="ctr">
-                      <a:solidFill>
-                        <a:srgbClr val="BFBFBF"/>
-                      </a:solidFill>
-                      <a:prstDash val="solid"/>
-                      <a:round/>
-                      <a:headEnd type="none" w="med" len="med"/>
-                      <a:tailEnd type="none" w="med" len="med"/>
-                    </a:lnB>
-                    <a:solidFill>
-                      <a:srgbClr val="F2F2F2"/>
-                    </a:solidFill>
-                  </a:tcPr>
-                </a:tc>
-                <a:tc>
-                  <a:txBody>
-                    <a:bodyPr/>
-                    <a:lstStyle/>
-                    <a:p>
-                      <a:pPr algn="r" indent="0" marL="0">
-                        <a:buNone/>
-                      </a:pPr>
-                      <a:r>
-                        <a:rPr lang="en-US" sz="1600" b="1" dirty="0">
-                          <a:solidFill>
-                            <a:schemeClr val="tx1"/>
-                          </a:solidFill>
-                        </a:rPr>
-                        <a:t>%</a:t>
-                      </a:r>
-                      <a:endParaRPr lang="en-US" sz="1600" dirty="0"/>
-                    </a:p>
-                  </a:txBody>
-                  <a:tcPr marL="76200" marR="76200" marT="38100" marB="38100" anchor="ctr">
-                    <a:lnL w="9525" cap="flat" cmpd="sng" algn="ctr">
-                      <a:solidFill>
-                        <a:srgbClr val="BFBFBF"/>
-                      </a:solidFill>
-                      <a:prstDash val="solid"/>
-                      <a:round/>
-                      <a:headEnd type="none" w="med" len="med"/>
-                      <a:tailEnd type="none" w="med" len="med"/>
-                    </a:lnL>
-                    <a:lnR w="9525" cap="flat" cmpd="sng" algn="ctr">
-                      <a:solidFill>
-                        <a:srgbClr val="BFBFBF"/>
-                      </a:solidFill>
-                      <a:prstDash val="solid"/>
-                      <a:round/>
-                      <a:headEnd type="none" w="med" len="med"/>
-                      <a:tailEnd type="none" w="med" len="med"/>
-                    </a:lnR>
-                    <a:lnT w="9525" cap="flat" cmpd="sng" algn="ctr">
-                      <a:solidFill>
-                        <a:srgbClr val="BFBFBF"/>
-                      </a:solidFill>
-                      <a:prstDash val="solid"/>
-                      <a:round/>
-                      <a:headEnd type="none" w="med" len="med"/>
-                      <a:tailEnd type="none" w="med" len="med"/>
-                    </a:lnT>
-                    <a:lnB w="9525" cap="flat" cmpd="sng" algn="ctr">
-                      <a:solidFill>
-                        <a:srgbClr val="BFBFBF"/>
-                      </a:solidFill>
-                      <a:prstDash val="solid"/>
-                      <a:round/>
-                      <a:headEnd type="none" w="med" len="med"/>
-                      <a:tailEnd type="none" w="med" len="med"/>
-                    </a:lnB>
-                    <a:solidFill>
-                      <a:srgbClr val="F2F2F2"/>
-                    </a:solidFill>
-                  </a:tcPr>
-                </a:tc>
-              </a:tr>
-              <a:tr h="310896">
-                <a:tc>
-                  <a:txBody>
-                    <a:bodyPr/>
-                    <a:lstStyle/>
-                    <a:p>
-                      <a:pPr algn="l" indent="0" marL="0">
-                        <a:buNone/>
-                      </a:pPr>
-                      <a:r>
-                        <a:rPr lang="en-US" sz="1600" dirty="0">
-                          <a:solidFill>
-                            <a:schemeClr val="tx1"/>
-                          </a:solidFill>
-                        </a:rPr>
-                        <a:t>Hệ thống Pulse</a:t>
-                      </a:r>
-                      <a:endParaRPr lang="en-US" sz="1600" dirty="0"/>
-                    </a:p>
-                  </a:txBody>
-                  <a:tcPr marL="76200" marR="76200" marT="38100" marB="38100" anchor="ctr">
-                    <a:lnL w="9525" cap="flat" cmpd="sng" algn="ctr">
-                      <a:solidFill>
-                        <a:srgbClr val="BFBFBF"/>
-                      </a:solidFill>
-                      <a:prstDash val="solid"/>
-                      <a:round/>
-                      <a:headEnd type="none" w="med" len="med"/>
-                      <a:tailEnd type="none" w="med" len="med"/>
-                    </a:lnL>
-                    <a:lnR w="9525" cap="flat" cmpd="sng" algn="ctr">
-                      <a:solidFill>
-                        <a:srgbClr val="BFBFBF"/>
-                      </a:solidFill>
-                      <a:prstDash val="solid"/>
-                      <a:round/>
-                      <a:headEnd type="none" w="med" len="med"/>
-                      <a:tailEnd type="none" w="med" len="med"/>
-                    </a:lnR>
-                    <a:lnT w="9525" cap="flat" cmpd="sng" algn="ctr">
-                      <a:solidFill>
-                        <a:srgbClr val="BFBFBF"/>
-                      </a:solidFill>
-                      <a:prstDash val="solid"/>
-                      <a:round/>
-                      <a:headEnd type="none" w="med" len="med"/>
-                      <a:tailEnd type="none" w="med" len="med"/>
-                    </a:lnT>
-                    <a:lnB w="9525" cap="flat" cmpd="sng" algn="ctr">
-                      <a:solidFill>
-                        <a:srgbClr val="BFBFBF"/>
-                      </a:solidFill>
-                      <a:prstDash val="solid"/>
-                      <a:round/>
-                      <a:headEnd type="none" w="med" len="med"/>
-                      <a:tailEnd type="none" w="med" len="med"/>
-                    </a:lnB>
-                  </a:tcPr>
-                </a:tc>
-                <a:tc>
-                  <a:txBody>
-                    <a:bodyPr/>
-                    <a:lstStyle/>
-                    <a:p>
-                      <a:pPr algn="r" indent="0" marL="0">
-                        <a:buNone/>
-                      </a:pPr>
-                      <a:r>
-                        <a:rPr lang="en-US" sz="1600" dirty="0">
-                          <a:solidFill>
-                            <a:schemeClr val="tx1"/>
-                          </a:solidFill>
-                        </a:rPr>
-                        <a:t>~92%</a:t>
-                      </a:r>
-                      <a:endParaRPr lang="en-US" sz="1600" dirty="0"/>
-                    </a:p>
-                  </a:txBody>
-                  <a:tcPr marL="76200" marR="76200" marT="38100" marB="38100" anchor="ctr">
-                    <a:lnL w="9525" cap="flat" cmpd="sng" algn="ctr">
-                      <a:solidFill>
-                        <a:srgbClr val="BFBFBF"/>
-                      </a:solidFill>
-                      <a:prstDash val="solid"/>
-                      <a:round/>
-                      <a:headEnd type="none" w="med" len="med"/>
-                      <a:tailEnd type="none" w="med" len="med"/>
-                    </a:lnL>
-                    <a:lnR w="9525" cap="flat" cmpd="sng" algn="ctr">
-                      <a:solidFill>
-                        <a:srgbClr val="BFBFBF"/>
-                      </a:solidFill>
-                      <a:prstDash val="solid"/>
-                      <a:round/>
-                      <a:headEnd type="none" w="med" len="med"/>
-                      <a:tailEnd type="none" w="med" len="med"/>
-                    </a:lnR>
-                    <a:lnT w="9525" cap="flat" cmpd="sng" algn="ctr">
-                      <a:solidFill>
-                        <a:srgbClr val="BFBFBF"/>
-                      </a:solidFill>
-                      <a:prstDash val="solid"/>
-                      <a:round/>
-                      <a:headEnd type="none" w="med" len="med"/>
-                      <a:tailEnd type="none" w="med" len="med"/>
-                    </a:lnT>
-                    <a:lnB w="9525" cap="flat" cmpd="sng" algn="ctr">
-                      <a:solidFill>
-                        <a:srgbClr val="BFBFBF"/>
-                      </a:solidFill>
-                      <a:prstDash val="solid"/>
-                      <a:round/>
-                      <a:headEnd type="none" w="med" len="med"/>
-                      <a:tailEnd type="none" w="med" len="med"/>
-                    </a:lnB>
-                  </a:tcPr>
-                </a:tc>
-              </a:tr>
-              <a:tr h="310896">
-                <a:tc>
-                  <a:txBody>
-                    <a:bodyPr/>
-                    <a:lstStyle/>
-                    <a:p>
-                      <a:pPr algn="l" indent="0" marL="0">
-                        <a:buNone/>
-                      </a:pPr>
-                      <a:r>
-                        <a:rPr lang="en-US" sz="1600" dirty="0">
-                          <a:solidFill>
-                            <a:schemeClr val="tx1"/>
-                          </a:solidFill>
-                        </a:rPr>
-                        <a:t>Đánh giá Pulse ML</a:t>
-                      </a:r>
-                      <a:endParaRPr lang="en-US" sz="1600" dirty="0"/>
-                    </a:p>
-                  </a:txBody>
-                  <a:tcPr marL="76200" marR="76200" marT="38100" marB="38100" anchor="ctr">
-                    <a:lnL w="9525" cap="flat" cmpd="sng" algn="ctr">
-                      <a:solidFill>
-                        <a:srgbClr val="BFBFBF"/>
-                      </a:solidFill>
-                      <a:prstDash val="solid"/>
-                      <a:round/>
-                      <a:headEnd type="none" w="med" len="med"/>
-                      <a:tailEnd type="none" w="med" len="med"/>
-                    </a:lnL>
-                    <a:lnR w="9525" cap="flat" cmpd="sng" algn="ctr">
-                      <a:solidFill>
-                        <a:srgbClr val="BFBFBF"/>
-                      </a:solidFill>
-                      <a:prstDash val="solid"/>
-                      <a:round/>
-                      <a:headEnd type="none" w="med" len="med"/>
-                      <a:tailEnd type="none" w="med" len="med"/>
-                    </a:lnR>
-                    <a:lnT w="9525" cap="flat" cmpd="sng" algn="ctr">
-                      <a:solidFill>
-                        <a:srgbClr val="BFBFBF"/>
-                      </a:solidFill>
-                      <a:prstDash val="solid"/>
-                      <a:round/>
-                      <a:headEnd type="none" w="med" len="med"/>
-                      <a:tailEnd type="none" w="med" len="med"/>
-                    </a:lnT>
-                    <a:lnB w="9525" cap="flat" cmpd="sng" algn="ctr">
-                      <a:solidFill>
-                        <a:srgbClr val="BFBFBF"/>
-                      </a:solidFill>
-                      <a:prstDash val="solid"/>
-                      <a:round/>
-                      <a:headEnd type="none" w="med" len="med"/>
-                      <a:tailEnd type="none" w="med" len="med"/>
-                    </a:lnB>
-                  </a:tcPr>
-                </a:tc>
-                <a:tc>
-                  <a:txBody>
-                    <a:bodyPr/>
-                    <a:lstStyle/>
-                    <a:p>
-                      <a:pPr algn="r" indent="0" marL="0">
-                        <a:buNone/>
-                      </a:pPr>
-                      <a:r>
-                        <a:rPr lang="en-US" sz="1600" dirty="0">
-                          <a:solidFill>
-                            <a:schemeClr val="tx1"/>
-                          </a:solidFill>
-                        </a:rPr>
-                        <a:t>~90%</a:t>
-                      </a:r>
-                      <a:endParaRPr lang="en-US" sz="1600" dirty="0"/>
-                    </a:p>
-                  </a:txBody>
-                  <a:tcPr marL="76200" marR="76200" marT="38100" marB="38100" anchor="ctr">
-                    <a:lnL w="9525" cap="flat" cmpd="sng" algn="ctr">
-                      <a:solidFill>
-                        <a:srgbClr val="BFBFBF"/>
-                      </a:solidFill>
-                      <a:prstDash val="solid"/>
-                      <a:round/>
-                      <a:headEnd type="none" w="med" len="med"/>
-                      <a:tailEnd type="none" w="med" len="med"/>
-                    </a:lnL>
-                    <a:lnR w="9525" cap="flat" cmpd="sng" algn="ctr">
-                      <a:solidFill>
-                        <a:srgbClr val="BFBFBF"/>
-                      </a:solidFill>
-                      <a:prstDash val="solid"/>
-                      <a:round/>
-                      <a:headEnd type="none" w="med" len="med"/>
-                      <a:tailEnd type="none" w="med" len="med"/>
-                    </a:lnR>
-                    <a:lnT w="9525" cap="flat" cmpd="sng" algn="ctr">
-                      <a:solidFill>
-                        <a:srgbClr val="BFBFBF"/>
-                      </a:solidFill>
-                      <a:prstDash val="solid"/>
-                      <a:round/>
-                      <a:headEnd type="none" w="med" len="med"/>
-                      <a:tailEnd type="none" w="med" len="med"/>
-                    </a:lnT>
-                    <a:lnB w="9525" cap="flat" cmpd="sng" algn="ctr">
-                      <a:solidFill>
-                        <a:srgbClr val="BFBFBF"/>
-                      </a:solidFill>
-                      <a:prstDash val="solid"/>
-                      <a:round/>
-                      <a:headEnd type="none" w="med" len="med"/>
-                      <a:tailEnd type="none" w="med" len="med"/>
-                    </a:lnB>
-                  </a:tcPr>
-                </a:tc>
-              </a:tr>
-              <a:tr h="310896">
-                <a:tc>
-                  <a:txBody>
-                    <a:bodyPr/>
-                    <a:lstStyle/>
-                    <a:p>
-                      <a:pPr algn="l" indent="0" marL="0">
-                        <a:buNone/>
-                      </a:pPr>
-                      <a:r>
-                        <a:rPr lang="en-US" sz="1600" dirty="0">
-                          <a:solidFill>
-                            <a:schemeClr val="tx1"/>
-                          </a:solidFill>
-                        </a:rPr>
-                        <a:t>Thí nghiệm syscall + nhóm feature</a:t>
-                      </a:r>
-                      <a:endParaRPr lang="en-US" sz="1600" dirty="0"/>
-                    </a:p>
-                  </a:txBody>
-                  <a:tcPr marL="76200" marR="76200" marT="38100" marB="38100" anchor="ctr">
-                    <a:lnL w="9525" cap="flat" cmpd="sng" algn="ctr">
-                      <a:solidFill>
-                        <a:srgbClr val="BFBFBF"/>
-                      </a:solidFill>
-                      <a:prstDash val="solid"/>
-                      <a:round/>
-                      <a:headEnd type="none" w="med" len="med"/>
-                      <a:tailEnd type="none" w="med" len="med"/>
-                    </a:lnL>
-                    <a:lnR w="9525" cap="flat" cmpd="sng" algn="ctr">
-                      <a:solidFill>
-                        <a:srgbClr val="BFBFBF"/>
-                      </a:solidFill>
-                      <a:prstDash val="solid"/>
-                      <a:round/>
-                      <a:headEnd type="none" w="med" len="med"/>
-                      <a:tailEnd type="none" w="med" len="med"/>
-                    </a:lnR>
-                    <a:lnT w="9525" cap="flat" cmpd="sng" algn="ctr">
-                      <a:solidFill>
-                        <a:srgbClr val="BFBFBF"/>
-                      </a:solidFill>
-                      <a:prstDash val="solid"/>
-                      <a:round/>
-                      <a:headEnd type="none" w="med" len="med"/>
-                      <a:tailEnd type="none" w="med" len="med"/>
-                    </a:lnT>
-                    <a:lnB w="9525" cap="flat" cmpd="sng" algn="ctr">
-                      <a:solidFill>
-                        <a:srgbClr val="BFBFBF"/>
-                      </a:solidFill>
-                      <a:prstDash val="solid"/>
-                      <a:round/>
-                      <a:headEnd type="none" w="med" len="med"/>
-                      <a:tailEnd type="none" w="med" len="med"/>
-                    </a:lnB>
-                  </a:tcPr>
-                </a:tc>
-                <a:tc>
-                  <a:txBody>
-                    <a:bodyPr/>
-                    <a:lstStyle/>
-                    <a:p>
-                      <a:pPr algn="r" indent="0" marL="0">
-                        <a:buNone/>
-                      </a:pPr>
-                      <a:r>
-                        <a:rPr lang="en-US" sz="1600" dirty="0">
-                          <a:solidFill>
-                            <a:schemeClr val="tx1"/>
-                          </a:solidFill>
-                        </a:rPr>
-                        <a:t>~95%</a:t>
-                      </a:r>
-                      <a:endParaRPr lang="en-US" sz="1600" dirty="0"/>
-                    </a:p>
-                  </a:txBody>
-                  <a:tcPr marL="76200" marR="76200" marT="38100" marB="38100" anchor="ctr">
-                    <a:lnL w="9525" cap="flat" cmpd="sng" algn="ctr">
-                      <a:solidFill>
-                        <a:srgbClr val="BFBFBF"/>
-                      </a:solidFill>
-                      <a:prstDash val="solid"/>
-                      <a:round/>
-                      <a:headEnd type="none" w="med" len="med"/>
-                      <a:tailEnd type="none" w="med" len="med"/>
-                    </a:lnL>
-                    <a:lnR w="9525" cap="flat" cmpd="sng" algn="ctr">
-                      <a:solidFill>
-                        <a:srgbClr val="BFBFBF"/>
-                      </a:solidFill>
-                      <a:prstDash val="solid"/>
-                      <a:round/>
-                      <a:headEnd type="none" w="med" len="med"/>
-                      <a:tailEnd type="none" w="med" len="med"/>
-                    </a:lnR>
-                    <a:lnT w="9525" cap="flat" cmpd="sng" algn="ctr">
-                      <a:solidFill>
-                        <a:srgbClr val="BFBFBF"/>
-                      </a:solidFill>
-                      <a:prstDash val="solid"/>
-                      <a:round/>
-                      <a:headEnd type="none" w="med" len="med"/>
-                      <a:tailEnd type="none" w="med" len="med"/>
-                    </a:lnT>
-                    <a:lnB w="9525" cap="flat" cmpd="sng" algn="ctr">
-                      <a:solidFill>
-                        <a:srgbClr val="BFBFBF"/>
-                      </a:solidFill>
-                      <a:prstDash val="solid"/>
-                      <a:round/>
-                      <a:headEnd type="none" w="med" len="med"/>
-                      <a:tailEnd type="none" w="med" len="med"/>
-                    </a:lnB>
-                  </a:tcPr>
-                </a:tc>
-              </a:tr>
-              <a:tr h="310896">
-                <a:tc>
-                  <a:txBody>
-                    <a:bodyPr/>
-                    <a:lstStyle/>
-                    <a:p>
-                      <a:pPr algn="l" indent="0" marL="0">
-                        <a:buNone/>
-                      </a:pPr>
-                      <a:r>
-                        <a:rPr lang="en-US" sz="1600" dirty="0">
-                          <a:solidFill>
-                            <a:schemeClr val="tx1"/>
-                          </a:solidFill>
-                        </a:rPr>
-                        <a:t>RCA</a:t>
-                      </a:r>
-                      <a:endParaRPr lang="en-US" sz="1600" dirty="0"/>
-                    </a:p>
-                  </a:txBody>
-                  <a:tcPr marL="76200" marR="76200" marT="38100" marB="38100" anchor="ctr">
-                    <a:lnL w="9525" cap="flat" cmpd="sng" algn="ctr">
-                      <a:solidFill>
-                        <a:srgbClr val="BFBFBF"/>
-                      </a:solidFill>
-                      <a:prstDash val="solid"/>
-                      <a:round/>
-                      <a:headEnd type="none" w="med" len="med"/>
-                      <a:tailEnd type="none" w="med" len="med"/>
-                    </a:lnL>
-                    <a:lnR w="9525" cap="flat" cmpd="sng" algn="ctr">
-                      <a:solidFill>
-                        <a:srgbClr val="BFBFBF"/>
-                      </a:solidFill>
-                      <a:prstDash val="solid"/>
-                      <a:round/>
-                      <a:headEnd type="none" w="med" len="med"/>
-                      <a:tailEnd type="none" w="med" len="med"/>
-                    </a:lnR>
-                    <a:lnT w="9525" cap="flat" cmpd="sng" algn="ctr">
-                      <a:solidFill>
-                        <a:srgbClr val="BFBFBF"/>
-                      </a:solidFill>
-                      <a:prstDash val="solid"/>
-                      <a:round/>
-                      <a:headEnd type="none" w="med" len="med"/>
-                      <a:tailEnd type="none" w="med" len="med"/>
-                    </a:lnT>
-                    <a:lnB w="9525" cap="flat" cmpd="sng" algn="ctr">
-                      <a:solidFill>
-                        <a:srgbClr val="BFBFBF"/>
-                      </a:solidFill>
-                      <a:prstDash val="solid"/>
-                      <a:round/>
-                      <a:headEnd type="none" w="med" len="med"/>
-                      <a:tailEnd type="none" w="med" len="med"/>
-                    </a:lnB>
-                  </a:tcPr>
-                </a:tc>
-                <a:tc>
-                  <a:txBody>
-                    <a:bodyPr/>
-                    <a:lstStyle/>
-                    <a:p>
-                      <a:pPr algn="r" indent="0" marL="0">
-                        <a:buNone/>
-                      </a:pPr>
-                      <a:r>
-                        <a:rPr lang="en-US" sz="1600" dirty="0">
-                          <a:solidFill>
-                            <a:schemeClr val="tx1"/>
-                          </a:solidFill>
-                        </a:rPr>
-                        <a:t>~92%</a:t>
-                      </a:r>
-                      <a:endParaRPr lang="en-US" sz="1600" dirty="0"/>
-                    </a:p>
-                  </a:txBody>
-                  <a:tcPr marL="76200" marR="76200" marT="38100" marB="38100" anchor="ctr">
-                    <a:lnL w="9525" cap="flat" cmpd="sng" algn="ctr">
-                      <a:solidFill>
-                        <a:srgbClr val="BFBFBF"/>
-                      </a:solidFill>
-                      <a:prstDash val="solid"/>
-                      <a:round/>
-                      <a:headEnd type="none" w="med" len="med"/>
-                      <a:tailEnd type="none" w="med" len="med"/>
-                    </a:lnL>
-                    <a:lnR w="9525" cap="flat" cmpd="sng" algn="ctr">
-                      <a:solidFill>
-                        <a:srgbClr val="BFBFBF"/>
-                      </a:solidFill>
-                      <a:prstDash val="solid"/>
-                      <a:round/>
-                      <a:headEnd type="none" w="med" len="med"/>
-                      <a:tailEnd type="none" w="med" len="med"/>
-                    </a:lnR>
-                    <a:lnT w="9525" cap="flat" cmpd="sng" algn="ctr">
-                      <a:solidFill>
-                        <a:srgbClr val="BFBFBF"/>
-                      </a:solidFill>
-                      <a:prstDash val="solid"/>
-                      <a:round/>
-                      <a:headEnd type="none" w="med" len="med"/>
-                      <a:tailEnd type="none" w="med" len="med"/>
-                    </a:lnT>
-                    <a:lnB w="9525" cap="flat" cmpd="sng" algn="ctr">
-                      <a:solidFill>
-                        <a:srgbClr val="BFBFBF"/>
-                      </a:solidFill>
-                      <a:prstDash val="solid"/>
-                      <a:round/>
-                      <a:headEnd type="none" w="med" len="med"/>
-                      <a:tailEnd type="none" w="med" len="med"/>
-                    </a:lnB>
-                  </a:tcPr>
-                </a:tc>
-              </a:tr>
-              <a:tr h="310896">
-                <a:tc>
-                  <a:txBody>
-                    <a:bodyPr/>
-                    <a:lstStyle/>
-                    <a:p>
-                      <a:pPr algn="l" indent="0" marL="0">
-                        <a:buNone/>
-                      </a:pPr>
-                      <a:r>
-                        <a:rPr lang="en-US" sz="1600" dirty="0">
-                          <a:solidFill>
-                            <a:schemeClr val="tx1"/>
-                          </a:solidFill>
-                        </a:rPr>
-                        <a:t>Baseline ML</a:t>
-                      </a:r>
-                      <a:endParaRPr lang="en-US" sz="1600" dirty="0"/>
-                    </a:p>
-                  </a:txBody>
-                  <a:tcPr marL="76200" marR="76200" marT="38100" marB="38100" anchor="ctr">
-                    <a:lnL w="9525" cap="flat" cmpd="sng" algn="ctr">
-                      <a:solidFill>
-                        <a:srgbClr val="BFBFBF"/>
-                      </a:solidFill>
-                      <a:prstDash val="solid"/>
-                      <a:round/>
-                      <a:headEnd type="none" w="med" len="med"/>
-                      <a:tailEnd type="none" w="med" len="med"/>
-                    </a:lnL>
-                    <a:lnR w="9525" cap="flat" cmpd="sng" algn="ctr">
-                      <a:solidFill>
-                        <a:srgbClr val="BFBFBF"/>
-                      </a:solidFill>
-                      <a:prstDash val="solid"/>
-                      <a:round/>
-                      <a:headEnd type="none" w="med" len="med"/>
-                      <a:tailEnd type="none" w="med" len="med"/>
-                    </a:lnR>
-                    <a:lnT w="9525" cap="flat" cmpd="sng" algn="ctr">
-                      <a:solidFill>
-                        <a:srgbClr val="BFBFBF"/>
-                      </a:solidFill>
-                      <a:prstDash val="solid"/>
-                      <a:round/>
-                      <a:headEnd type="none" w="med" len="med"/>
-                      <a:tailEnd type="none" w="med" len="med"/>
-                    </a:lnT>
-                    <a:lnB w="9525" cap="flat" cmpd="sng" algn="ctr">
-                      <a:solidFill>
-                        <a:srgbClr val="BFBFBF"/>
-                      </a:solidFill>
-                      <a:prstDash val="solid"/>
-                      <a:round/>
-                      <a:headEnd type="none" w="med" len="med"/>
-                      <a:tailEnd type="none" w="med" len="med"/>
-                    </a:lnB>
-                  </a:tcPr>
-                </a:tc>
-                <a:tc>
-                  <a:txBody>
-                    <a:bodyPr/>
-                    <a:lstStyle/>
-                    <a:p>
-                      <a:pPr algn="r" indent="0" marL="0">
-                        <a:buNone/>
-                      </a:pPr>
-                      <a:r>
-                        <a:rPr lang="en-US" sz="1600" dirty="0">
-                          <a:solidFill>
-                            <a:schemeClr val="tx1"/>
-                          </a:solidFill>
-                        </a:rPr>
-                        <a:t>~90%</a:t>
-                      </a:r>
-                      <a:endParaRPr lang="en-US" sz="1600" dirty="0"/>
-                    </a:p>
-                  </a:txBody>
-                  <a:tcPr marL="76200" marR="76200" marT="38100" marB="38100" anchor="ctr">
-                    <a:lnL w="9525" cap="flat" cmpd="sng" algn="ctr">
-                      <a:solidFill>
-                        <a:srgbClr val="BFBFBF"/>
-                      </a:solidFill>
-                      <a:prstDash val="solid"/>
-                      <a:round/>
-                      <a:headEnd type="none" w="med" len="med"/>
-                      <a:tailEnd type="none" w="med" len="med"/>
-                    </a:lnL>
-                    <a:lnR w="9525" cap="flat" cmpd="sng" algn="ctr">
-                      <a:solidFill>
-                        <a:srgbClr val="BFBFBF"/>
-                      </a:solidFill>
-                      <a:prstDash val="solid"/>
-                      <a:round/>
-                      <a:headEnd type="none" w="med" len="med"/>
-                      <a:tailEnd type="none" w="med" len="med"/>
-                    </a:lnR>
-                    <a:lnT w="9525" cap="flat" cmpd="sng" algn="ctr">
-                      <a:solidFill>
-                        <a:srgbClr val="BFBFBF"/>
-                      </a:solidFill>
-                      <a:prstDash val="solid"/>
-                      <a:round/>
-                      <a:headEnd type="none" w="med" len="med"/>
-                      <a:tailEnd type="none" w="med" len="med"/>
-                    </a:lnT>
-                    <a:lnB w="9525" cap="flat" cmpd="sng" algn="ctr">
-                      <a:solidFill>
-                        <a:srgbClr val="BFBFBF"/>
-                      </a:solidFill>
-                      <a:prstDash val="solid"/>
-                      <a:round/>
-                      <a:headEnd type="none" w="med" len="med"/>
-                      <a:tailEnd type="none" w="med" len="med"/>
-                    </a:lnB>
-                  </a:tcPr>
-                </a:tc>
-              </a:tr>
-              <a:tr h="310896">
-                <a:tc>
-                  <a:txBody>
-                    <a:bodyPr/>
-                    <a:lstStyle/>
-                    <a:p>
-                      <a:pPr algn="l" indent="0" marL="0">
-                        <a:buNone/>
-                      </a:pPr>
-                      <a:r>
-                        <a:rPr lang="en-US" sz="1600" dirty="0">
-                          <a:solidFill>
-                            <a:schemeClr val="tx1"/>
-                          </a:solidFill>
-                        </a:rPr>
-                        <a:t>Phần rule (làm sau ML)</a:t>
-                      </a:r>
-                      <a:endParaRPr lang="en-US" sz="1600" dirty="0"/>
-                    </a:p>
-                  </a:txBody>
-                  <a:tcPr marL="76200" marR="76200" marT="38100" marB="38100" anchor="ctr">
-                    <a:lnL w="9525" cap="flat" cmpd="sng" algn="ctr">
-                      <a:solidFill>
-                        <a:srgbClr val="BFBFBF"/>
-                      </a:solidFill>
-                      <a:prstDash val="solid"/>
-                      <a:round/>
-                      <a:headEnd type="none" w="med" len="med"/>
-                      <a:tailEnd type="none" w="med" len="med"/>
-                    </a:lnL>
-                    <a:lnR w="9525" cap="flat" cmpd="sng" algn="ctr">
-                      <a:solidFill>
-                        <a:srgbClr val="BFBFBF"/>
-                      </a:solidFill>
-                      <a:prstDash val="solid"/>
-                      <a:round/>
-                      <a:headEnd type="none" w="med" len="med"/>
-                      <a:tailEnd type="none" w="med" len="med"/>
-                    </a:lnR>
-                    <a:lnT w="9525" cap="flat" cmpd="sng" algn="ctr">
-                      <a:solidFill>
-                        <a:srgbClr val="BFBFBF"/>
-                      </a:solidFill>
-                      <a:prstDash val="solid"/>
-                      <a:round/>
-                      <a:headEnd type="none" w="med" len="med"/>
-                      <a:tailEnd type="none" w="med" len="med"/>
-                    </a:lnT>
-                    <a:lnB w="9525" cap="flat" cmpd="sng" algn="ctr">
-                      <a:solidFill>
-                        <a:srgbClr val="BFBFBF"/>
-                      </a:solidFill>
-                      <a:prstDash val="solid"/>
-                      <a:round/>
-                      <a:headEnd type="none" w="med" len="med"/>
-                      <a:tailEnd type="none" w="med" len="med"/>
-                    </a:lnB>
-                  </a:tcPr>
-                </a:tc>
-                <a:tc>
-                  <a:txBody>
-                    <a:bodyPr/>
-                    <a:lstStyle/>
-                    <a:p>
-                      <a:pPr algn="r" indent="0" marL="0">
-                        <a:buNone/>
-                      </a:pPr>
-                      <a:r>
-                        <a:rPr lang="en-US" sz="1600" dirty="0">
-                          <a:solidFill>
-                            <a:schemeClr val="tx1"/>
-                          </a:solidFill>
-                        </a:rPr>
-                        <a:t>~45%</a:t>
-                      </a:r>
-                      <a:endParaRPr lang="en-US" sz="1600" dirty="0"/>
-                    </a:p>
-                  </a:txBody>
-                  <a:tcPr marL="76200" marR="76200" marT="38100" marB="38100" anchor="ctr">
-                    <a:lnL w="9525" cap="flat" cmpd="sng" algn="ctr">
-                      <a:solidFill>
-                        <a:srgbClr val="BFBFBF"/>
-                      </a:solidFill>
-                      <a:prstDash val="solid"/>
-                      <a:round/>
-                      <a:headEnd type="none" w="med" len="med"/>
-                      <a:tailEnd type="none" w="med" len="med"/>
-                    </a:lnL>
-                    <a:lnR w="9525" cap="flat" cmpd="sng" algn="ctr">
-                      <a:solidFill>
-                        <a:srgbClr val="BFBFBF"/>
-                      </a:solidFill>
-                      <a:prstDash val="solid"/>
-                      <a:round/>
-                      <a:headEnd type="none" w="med" len="med"/>
-                      <a:tailEnd type="none" w="med" len="med"/>
-                    </a:lnR>
-                    <a:lnT w="9525" cap="flat" cmpd="sng" algn="ctr">
-                      <a:solidFill>
-                        <a:srgbClr val="BFBFBF"/>
-                      </a:solidFill>
-                      <a:prstDash val="solid"/>
-                      <a:round/>
-                      <a:headEnd type="none" w="med" len="med"/>
-                      <a:tailEnd type="none" w="med" len="med"/>
-                    </a:lnT>
-                    <a:lnB w="9525" cap="flat" cmpd="sng" algn="ctr">
-                      <a:solidFill>
-                        <a:srgbClr val="BFBFBF"/>
-                      </a:solidFill>
-                      <a:prstDash val="solid"/>
-                      <a:round/>
-                      <a:headEnd type="none" w="med" len="med"/>
-                      <a:tailEnd type="none" w="med" len="med"/>
-                    </a:lnB>
-                  </a:tcPr>
-                </a:tc>
-              </a:tr>
-              <a:tr h="310896">
-                <a:tc>
-                  <a:txBody>
-                    <a:bodyPr/>
-                    <a:lstStyle/>
-                    <a:p>
-                      <a:pPr algn="l" indent="0" marL="0">
-                        <a:buNone/>
-                      </a:pPr>
-                      <a:r>
-                        <a:rPr lang="en-US" sz="1600" dirty="0">
-                          <a:solidFill>
-                            <a:schemeClr val="tx1"/>
-                          </a:solidFill>
-                        </a:rPr>
-                        <a:t>Viết luận văn</a:t>
-                      </a:r>
-                      <a:endParaRPr lang="en-US" sz="1600" dirty="0"/>
-                    </a:p>
-                  </a:txBody>
-                  <a:tcPr marL="76200" marR="76200" marT="38100" marB="38100" anchor="ctr">
-                    <a:lnL w="9525" cap="flat" cmpd="sng" algn="ctr">
-                      <a:solidFill>
-                        <a:srgbClr val="BFBFBF"/>
-                      </a:solidFill>
-                      <a:prstDash val="solid"/>
-                      <a:round/>
-                      <a:headEnd type="none" w="med" len="med"/>
-                      <a:tailEnd type="none" w="med" len="med"/>
-                    </a:lnL>
-                    <a:lnR w="9525" cap="flat" cmpd="sng" algn="ctr">
-                      <a:solidFill>
-                        <a:srgbClr val="BFBFBF"/>
-                      </a:solidFill>
-                      <a:prstDash val="solid"/>
-                      <a:round/>
-                      <a:headEnd type="none" w="med" len="med"/>
-                      <a:tailEnd type="none" w="med" len="med"/>
-                    </a:lnR>
-                    <a:lnT w="9525" cap="flat" cmpd="sng" algn="ctr">
-                      <a:solidFill>
-                        <a:srgbClr val="BFBFBF"/>
-                      </a:solidFill>
-                      <a:prstDash val="solid"/>
-                      <a:round/>
-                      <a:headEnd type="none" w="med" len="med"/>
-                      <a:tailEnd type="none" w="med" len="med"/>
-                    </a:lnT>
-                    <a:lnB w="9525" cap="flat" cmpd="sng" algn="ctr">
-                      <a:solidFill>
-                        <a:srgbClr val="BFBFBF"/>
-                      </a:solidFill>
-                      <a:prstDash val="solid"/>
-                      <a:round/>
-                      <a:headEnd type="none" w="med" len="med"/>
-                      <a:tailEnd type="none" w="med" len="med"/>
-                    </a:lnB>
-                  </a:tcPr>
-                </a:tc>
-                <a:tc>
-                  <a:txBody>
-                    <a:bodyPr/>
-                    <a:lstStyle/>
-                    <a:p>
-                      <a:pPr algn="r" indent="0" marL="0">
-                        <a:buNone/>
-                      </a:pPr>
-                      <a:r>
-                        <a:rPr lang="en-US" sz="1600" dirty="0">
-                          <a:solidFill>
-                            <a:schemeClr val="tx1"/>
-                          </a:solidFill>
-                        </a:rPr>
-                        <a:t>~10%</a:t>
-                      </a:r>
-                      <a:endParaRPr lang="en-US" sz="1600" dirty="0"/>
-                    </a:p>
-                  </a:txBody>
-                  <a:tcPr marL="76200" marR="76200" marT="38100" marB="38100" anchor="ctr">
-                    <a:lnL w="9525" cap="flat" cmpd="sng" algn="ctr">
-                      <a:solidFill>
-                        <a:srgbClr val="BFBFBF"/>
-                      </a:solidFill>
-                      <a:prstDash val="solid"/>
-                      <a:round/>
-                      <a:headEnd type="none" w="med" len="med"/>
-                      <a:tailEnd type="none" w="med" len="med"/>
-                    </a:lnL>
-                    <a:lnR w="9525" cap="flat" cmpd="sng" algn="ctr">
-                      <a:solidFill>
-                        <a:srgbClr val="BFBFBF"/>
-                      </a:solidFill>
-                      <a:prstDash val="solid"/>
-                      <a:round/>
-                      <a:headEnd type="none" w="med" len="med"/>
-                      <a:tailEnd type="none" w="med" len="med"/>
-                    </a:lnR>
-                    <a:lnT w="9525" cap="flat" cmpd="sng" algn="ctr">
-                      <a:solidFill>
-                        <a:srgbClr val="BFBFBF"/>
-                      </a:solidFill>
-                      <a:prstDash val="solid"/>
-                      <a:round/>
-                      <a:headEnd type="none" w="med" len="med"/>
-                      <a:tailEnd type="none" w="med" len="med"/>
-                    </a:lnT>
-                    <a:lnB w="9525" cap="flat" cmpd="sng" algn="ctr">
-                      <a:solidFill>
-                        <a:srgbClr val="BFBFBF"/>
-                      </a:solidFill>
-                      <a:prstDash val="solid"/>
-                      <a:round/>
-                      <a:headEnd type="none" w="med" len="med"/>
-                      <a:tailEnd type="none" w="med" len="med"/>
-                    </a:lnB>
-                  </a:tcPr>
-                </a:tc>
-              </a:tr>
-              <a:tr h="310896">
-                <a:tc>
-                  <a:txBody>
-                    <a:bodyPr/>
-                    <a:lstStyle/>
-                    <a:p>
-                      <a:pPr algn="l" indent="0" marL="0">
-                        <a:buNone/>
-                      </a:pPr>
-                      <a:r>
-                        <a:rPr lang="en-US" sz="1600" b="1" dirty="0">
-                          <a:solidFill>
-                            <a:schemeClr val="tx1"/>
-                          </a:solidFill>
-                        </a:rPr>
-                        <a:t>Luận văn tổng thể</a:t>
-                      </a:r>
-                      <a:endParaRPr lang="en-US" sz="1600" dirty="0"/>
-                    </a:p>
-                  </a:txBody>
-                  <a:tcPr marL="76200" marR="76200" marT="38100" marB="38100" anchor="ctr">
-                    <a:lnL w="9525" cap="flat" cmpd="sng" algn="ctr">
-                      <a:solidFill>
-                        <a:srgbClr val="BFBFBF"/>
-                      </a:solidFill>
-                      <a:prstDash val="solid"/>
-                      <a:round/>
-                      <a:headEnd type="none" w="med" len="med"/>
-                      <a:tailEnd type="none" w="med" len="med"/>
-                    </a:lnL>
-                    <a:lnR w="9525" cap="flat" cmpd="sng" algn="ctr">
-                      <a:solidFill>
-                        <a:srgbClr val="BFBFBF"/>
-                      </a:solidFill>
-                      <a:prstDash val="solid"/>
-                      <a:round/>
-                      <a:headEnd type="none" w="med" len="med"/>
-                      <a:tailEnd type="none" w="med" len="med"/>
-                    </a:lnR>
-                    <a:lnT w="9525" cap="flat" cmpd="sng" algn="ctr">
-                      <a:solidFill>
-                        <a:srgbClr val="BFBFBF"/>
-                      </a:solidFill>
-                      <a:prstDash val="solid"/>
-                      <a:round/>
-                      <a:headEnd type="none" w="med" len="med"/>
-                      <a:tailEnd type="none" w="med" len="med"/>
-                    </a:lnT>
-                    <a:lnB w="9525" cap="flat" cmpd="sng" algn="ctr">
-                      <a:solidFill>
-                        <a:srgbClr val="BFBFBF"/>
-                      </a:solidFill>
-                      <a:prstDash val="solid"/>
-                      <a:round/>
-                      <a:headEnd type="none" w="med" len="med"/>
-                      <a:tailEnd type="none" w="med" len="med"/>
-                    </a:lnB>
-                  </a:tcPr>
-                </a:tc>
-                <a:tc>
-                  <a:txBody>
-                    <a:bodyPr/>
-                    <a:lstStyle/>
-                    <a:p>
-                      <a:pPr algn="r" indent="0" marL="0">
-                        <a:buNone/>
-                      </a:pPr>
-                      <a:r>
-                        <a:rPr lang="en-US" sz="1600" b="1" dirty="0">
-                          <a:solidFill>
-                            <a:schemeClr val="tx1"/>
-                          </a:solidFill>
-                        </a:rPr>
-                        <a:t>~78%</a:t>
-                      </a:r>
-                      <a:endParaRPr lang="en-US" sz="1600" dirty="0"/>
-                    </a:p>
-                  </a:txBody>
-                  <a:tcPr marL="76200" marR="76200" marT="38100" marB="38100" anchor="ctr">
-                    <a:lnL w="9525" cap="flat" cmpd="sng" algn="ctr">
-                      <a:solidFill>
-                        <a:srgbClr val="BFBFBF"/>
-                      </a:solidFill>
-                      <a:prstDash val="solid"/>
-                      <a:round/>
-                      <a:headEnd type="none" w="med" len="med"/>
-                      <a:tailEnd type="none" w="med" len="med"/>
-                    </a:lnL>
-                    <a:lnR w="9525" cap="flat" cmpd="sng" algn="ctr">
-                      <a:solidFill>
-                        <a:srgbClr val="BFBFBF"/>
-                      </a:solidFill>
-                      <a:prstDash val="solid"/>
-                      <a:round/>
-                      <a:headEnd type="none" w="med" len="med"/>
-                      <a:tailEnd type="none" w="med" len="med"/>
-                    </a:lnR>
-                    <a:lnT w="9525" cap="flat" cmpd="sng" algn="ctr">
-                      <a:solidFill>
-                        <a:srgbClr val="BFBFBF"/>
-                      </a:solidFill>
-                      <a:prstDash val="solid"/>
-                      <a:round/>
-                      <a:headEnd type="none" w="med" len="med"/>
-                      <a:tailEnd type="none" w="med" len="med"/>
-                    </a:lnT>
-                    <a:lnB w="9525" cap="flat" cmpd="sng" algn="ctr">
-                      <a:solidFill>
-                        <a:srgbClr val="BFBFBF"/>
-                      </a:solidFill>
-                      <a:prstDash val="solid"/>
-                      <a:round/>
-                      <a:headEnd type="none" w="med" len="med"/>
-                      <a:tailEnd type="none" w="med" len="med"/>
-                    </a:lnB>
-                  </a:tcPr>
-                </a:tc>
-              </a:tr>
-            </a:tbl>
-          </a:graphicData>
-        </a:graphic>
-      </p:graphicFrame>
       <p:sp>
         <p:nvSpPr>
-          <p:cNvPr id="4" name="Nội dung"/>
+          <p:cNvPr id="3" name="Nội dung"/>
           <p:cNvSpPr txBox="1"/>
           <p:nvPr/>
         </p:nvSpPr>
         <p:spPr>
           <a:xfrm>
-            <a:off x="5760720" y="1024128"/>
-            <a:ext cx="5943600" cy="5120640"/>
+            <a:off x="813816" y="1024128"/>
+            <a:ext cx="10881360" cy="5120640"/>
           </a:xfrm>
           <a:prstGeom prst="rect">
             <a:avLst/>
@@ -14042,7 +14591,7 @@
                   <a:schemeClr val="tx1"/>
                 </a:solidFill>
               </a:rPr>
-              <a:t>24/10: </a:t>
+              <a:t>24/10, sau lượt xác nhận: </a:t>
             </a:r>
             <a:r>
               <a:rPr lang="en-US" sz="1800" dirty="0">
@@ -14050,7 +14599,7 @@
                   <a:schemeClr val="tx1"/>
                 </a:solidFill>
               </a:rPr>
-              <a:t>đọc lượt xác nhận (4 kỳ vọng, gánh cảnh báo, test blind giảm gánh, RCA)</a:t>
+              <a:t>đọc 4 kỳ vọng theo tốc độ attack, gánh cảnh báo live, test blind hướng giảm gánh, số liệu RCA; ghép đợt cảnh báo với thời điểm kernel để có độ trễ kernel → người nhận</a:t>
             </a:r>
             <a:endParaRPr lang="en-US" sz="1800" dirty="0"/>
           </a:p>
@@ -14076,7 +14625,7 @@
                   <a:schemeClr val="tx1"/>
                 </a:solidFill>
               </a:rPr>
-              <a:t>so sánh không rule / có rule trên cùng dữ liệu</a:t>
+              <a:t>chép log Falco, so sánh không rule / có rule trên cùng dữ liệu</a:t>
             </a:r>
             <a:endParaRPr lang="en-US" sz="1800" dirty="0"/>
           </a:p>
@@ -14094,7 +14643,7 @@
                   <a:schemeClr val="tx1"/>
                 </a:solidFill>
               </a:rPr>
-              <a:t>Chốt bằng chứng: </a:t>
+              <a:t>RCA: </a:t>
             </a:r>
             <a:r>
               <a:rPr lang="en-US" sz="1800" dirty="0">
@@ -14102,7 +14651,7 @@
                   <a:schemeClr val="tx1"/>
                 </a:solidFill>
               </a:rPr>
-              <a:t>nhóm feature dưới CUSUM chặn trần (đang chạy)</a:t>
+              <a:t>nhận trigger từ webhook Alertmanager (cảnh báo vận hành làm trigger) ở lượt sau</a:t>
             </a:r>
             <a:endParaRPr lang="en-US" sz="1800" dirty="0"/>
           </a:p>
@@ -14154,45 +14703,35 @@
                   <a:schemeClr val="tx1"/>
                 </a:solidFill>
               </a:rPr>
-              <a:t>gánh cảnh báo còn xa 0,1/giờ; binary vô hại; kịch bản attack đã biết (development)</a:t>
+              <a:t>gánh cảnh báo còn xa 0,1/giờ; binary vô hại vẫn bị gắn cờ; kịch bản attack đã biết (development)</a:t>
             </a:r>
             <a:endParaRPr lang="en-US" sz="1800" dirty="0"/>
           </a:p>
-        </p:txBody>
-      </p:sp>
-      <p:sp>
-        <p:nvSpPr>
-          <p:cNvPr id="5" name="Ghi chú"/>
-          <p:cNvSpPr txBox="1"/>
-          <p:nvPr/>
-        </p:nvSpPr>
-        <p:spPr>
-          <a:xfrm>
-            <a:off x="813816" y="6080760"/>
-            <a:ext cx="10881360" cy="365760"/>
-          </a:xfrm>
-          <a:prstGeom prst="rect">
-            <a:avLst/>
-          </a:prstGeom>
-          <a:noFill/>
-          <a:ln/>
-        </p:spPr>
-        <p:txBody>
-          <a:bodyPr wrap="square" lIns="635" tIns="635" rIns="635" bIns="635" rtlCol="0" anchor="t"/>
-          <a:lstStyle/>
           <a:p>
-            <a:pPr indent="0" marL="0">
-              <a:buNone/>
+            <a:pPr marL="228600" indent="-228600">
+              <a:spcAft>
+                <a:spcPts val="1000"/>
+              </a:spcAft>
+              <a:buSzPct val="100000"/>
+              <a:buChar char="•"/>
             </a:pPr>
             <a:r>
-              <a:rPr lang="en-US" sz="1200" dirty="0">
+              <a:rPr lang="en-US" sz="1800" b="1" dirty="0">
                 <a:solidFill>
                   <a:schemeClr val="tx1"/>
                 </a:solidFill>
               </a:rPr>
-              <a:t>Phần trăm là ước lượng theo khối việc còn lại, không phải đo chính xác.</a:t>
+              <a:t>Bằng chứng trong repo: </a:t>
             </a:r>
-            <a:endParaRPr lang="en-US" sz="1200" dirty="0"/>
+            <a:r>
+              <a:rPr lang="en-US" sz="1800" dirty="0">
+                <a:solidFill>
+                  <a:schemeClr val="tx1"/>
+                </a:solidFill>
+              </a:rPr>
+              <a:t>biên nhận 22–23/10 kèm nguồn gốc từng file, hai cây RCA thật, danh mục 75 tài liệu tham chiếu</a:t>
+            </a:r>
+            <a:endParaRPr lang="en-US" sz="1800" dirty="0"/>
           </a:p>
         </p:txBody>
       </p:sp>
@@ -15737,7 +16276,7 @@
                   <a:schemeClr val="tx1"/>
                 </a:solidFill>
               </a:rPr>
-              <a:t>Mỗi lượt: 3 worker, 24 giờ, 21 workload; campaign 315 cặp (control → binary vô hại → attack, 5 kịch bản × 3 tốc độ). </a:t>
+              <a:t>Mỗi lượt: 3 worker, 24 giờ, 21 workload; campaign 315 cặp (control → binary vô hại → attack, 5 kịch bản × 3 tốc độ: 6, 12, 24 lần/giây). </a:t>
             </a:r>
             <a:r>
               <a:rPr lang="en-US" sz="1600" b="1" dirty="0">
@@ -19767,7 +20306,7 @@
                   <a:schemeClr val="tx1"/>
                 </a:solidFill>
               </a:rPr>
-              <a:t>theo luật đăng ký trước (v1 ngày 19/10, v2 ngày 21/10), biên Pareto 58 chính sách có khoảng tin cậy</a:t>
+              <a:t>theo luật đăng ký trước (v1 ngày 19/10, v2 ngày 21/10), biên Pareto 58 chính sách</a:t>
             </a:r>
             <a:endParaRPr lang="en-US" sz="1800" dirty="0"/>
           </a:p>
@@ -21973,7 +22512,7 @@
                   <a:schemeClr val="tx1"/>
                 </a:solidFill>
               </a:rPr>
-              <a:t>AE và tree_ae recall +4,9 điểm nhưng khoảng cách attack − vô hại kém 26 điểm (CI dưới 0) → không thay base29</a:t>
+              <a:t>AE và tree_ae recall +4,9 điểm nhưng khoảng cách attack − vô hại kém 26 điểm → không thay base29</a:t>
             </a:r>
             <a:endParaRPr lang="en-US" sz="1800" dirty="0"/>
           </a:p>

</xml_diff>